<commit_message>
Switched the poster image with the optimal, 16km range network.
</commit_message>
<xml_diff>
--- a/Conference/DroneDefibrillator_202610041823.pptx
+++ b/Conference/DroneDefibrillator_202610041823.pptx
@@ -116,7 +116,7 @@
             <a:srgbClr val="A4A3A4"/>
           </p15:clr>
         </p15:guide>
-        <p15:guide id="2" pos="7937" userDrawn="1">
+        <p15:guide id="2" pos="7982" userDrawn="1">
           <p15:clr>
             <a:srgbClr val="A4A3A4"/>
           </p15:clr>
@@ -6801,7 +6801,7 @@
         </p:blipFill>
         <p:spPr>
           <a:xfrm>
-            <a:off x="10452896" y="7508755"/>
+            <a:off x="10452896" y="7123747"/>
             <a:ext cx="4294181" cy="4294181"/>
           </a:xfrm>
           <a:prstGeom prst="rect">
@@ -6823,7 +6823,7 @@
         </p:nvSpPr>
         <p:spPr>
           <a:xfrm>
-            <a:off x="1082843" y="6493093"/>
+            <a:off x="1082843" y="6108085"/>
             <a:ext cx="7916778" cy="5032147"/>
           </a:xfrm>
           <a:prstGeom prst="rect">
@@ -6903,7 +6903,7 @@
         </p:nvSpPr>
         <p:spPr>
           <a:xfrm>
-            <a:off x="16200355" y="6493093"/>
+            <a:off x="16200355" y="6108085"/>
             <a:ext cx="7916778" cy="5032147"/>
           </a:xfrm>
           <a:prstGeom prst="rect">
@@ -7886,7 +7886,7 @@
         </p:nvSpPr>
         <p:spPr>
           <a:xfrm>
-            <a:off x="9727361" y="6493093"/>
+            <a:off x="9727361" y="6108085"/>
             <a:ext cx="2715123" cy="1015663"/>
           </a:xfrm>
           <a:prstGeom prst="rect">
@@ -7922,7 +7922,7 @@
         </p:nvSpPr>
         <p:spPr>
           <a:xfrm>
-            <a:off x="12757491" y="6493092"/>
+            <a:off x="12757491" y="6108084"/>
             <a:ext cx="2715120" cy="1015663"/>
           </a:xfrm>
           <a:prstGeom prst="rect">
@@ -8079,7 +8079,7 @@
         </p:blipFill>
         <p:spPr>
           <a:xfrm>
-            <a:off x="6469795" y="13341767"/>
+            <a:off x="6469795" y="12475493"/>
             <a:ext cx="12260386" cy="7621064"/>
           </a:xfrm>
           <a:prstGeom prst="rect">
@@ -8101,7 +8101,7 @@
         </p:nvSpPr>
         <p:spPr>
           <a:xfrm>
-            <a:off x="1082843" y="12264976"/>
+            <a:off x="1082843" y="11398702"/>
             <a:ext cx="5386952" cy="8910131"/>
           </a:xfrm>
           <a:prstGeom prst="rect">
@@ -8289,7 +8289,7 @@
         </p:nvSpPr>
         <p:spPr>
           <a:xfrm>
-            <a:off x="18730180" y="12282986"/>
+            <a:off x="18730180" y="11416712"/>
             <a:ext cx="5386952" cy="8633133"/>
           </a:xfrm>
           <a:prstGeom prst="rect">
@@ -9361,14 +9361,13 @@
               </a:ext>
             </a:extLst>
           </a:blip>
-          <a:stretch>
-            <a:fillRect/>
-          </a:stretch>
+          <a:srcRect/>
+          <a:stretch/>
         </p:blipFill>
         <p:spPr>
           <a:xfrm>
-            <a:off x="8692650" y="22362286"/>
-            <a:ext cx="7712241" cy="4588868"/>
+            <a:off x="8692650" y="21175958"/>
+            <a:ext cx="7712241" cy="4507081"/>
           </a:xfrm>
           <a:prstGeom prst="rect">
             <a:avLst/>
@@ -9403,7 +9402,7 @@
         </p:blipFill>
         <p:spPr>
           <a:xfrm>
-            <a:off x="16404891" y="22386765"/>
+            <a:off x="16404891" y="21159544"/>
             <a:ext cx="7712242" cy="4539910"/>
           </a:xfrm>
           <a:prstGeom prst="rect">
@@ -9439,7 +9438,7 @@
         </p:blipFill>
         <p:spPr>
           <a:xfrm>
-            <a:off x="1082843" y="22378268"/>
+            <a:off x="1082843" y="21151047"/>
             <a:ext cx="7609807" cy="4519021"/>
           </a:xfrm>
           <a:prstGeom prst="rect">
@@ -9461,7 +9460,7 @@
         </p:nvSpPr>
         <p:spPr>
           <a:xfrm>
-            <a:off x="1092328" y="21636864"/>
+            <a:off x="1092328" y="20409643"/>
             <a:ext cx="11359640" cy="784830"/>
           </a:xfrm>
           <a:prstGeom prst="rect">
@@ -9497,7 +9496,7 @@
         </p:nvSpPr>
         <p:spPr>
           <a:xfrm>
-            <a:off x="12757492" y="21636864"/>
+            <a:off x="12757492" y="20409643"/>
             <a:ext cx="11359640" cy="784830"/>
           </a:xfrm>
           <a:prstGeom prst="rect">
@@ -9534,7 +9533,7 @@
         </p:nvSpPr>
         <p:spPr>
           <a:xfrm>
-            <a:off x="1092328" y="27393546"/>
+            <a:off x="1092328" y="26166325"/>
             <a:ext cx="11359640" cy="784830"/>
           </a:xfrm>
           <a:prstGeom prst="rect">
@@ -9570,7 +9569,7 @@
         </p:nvSpPr>
         <p:spPr>
           <a:xfrm>
-            <a:off x="12757492" y="27393546"/>
+            <a:off x="12757492" y="26166325"/>
             <a:ext cx="11359640" cy="784830"/>
           </a:xfrm>
           <a:prstGeom prst="rect">
@@ -9621,7 +9620,7 @@
         </p:blipFill>
         <p:spPr>
           <a:xfrm>
-            <a:off x="8032721" y="28109627"/>
+            <a:off x="8032721" y="26882406"/>
             <a:ext cx="9144019" cy="5486411"/>
           </a:xfrm>
           <a:prstGeom prst="rect">
@@ -9643,7 +9642,7 @@
         </p:nvSpPr>
         <p:spPr>
           <a:xfrm>
-            <a:off x="1095253" y="28176497"/>
+            <a:off x="1095253" y="26949276"/>
             <a:ext cx="6937468" cy="5632311"/>
           </a:xfrm>
           <a:prstGeom prst="rect">
@@ -9745,7 +9744,7 @@
         </p:nvSpPr>
         <p:spPr>
           <a:xfrm>
-            <a:off x="17176740" y="28176497"/>
+            <a:off x="17176740" y="26949276"/>
             <a:ext cx="6937468" cy="5632311"/>
           </a:xfrm>
           <a:prstGeom prst="rect">
@@ -9807,6 +9806,173 @@
               <a:t> the national chain of survival for sudden cardiac arrests.</a:t>
             </a:r>
             <a:endParaRPr lang="hu-HU" sz="2400" dirty="0"/>
+          </a:p>
+        </p:txBody>
+      </p:sp>
+      <p:sp>
+        <p:nvSpPr>
+          <p:cNvPr id="84" name="TextBox 83">
+            <a:extLst>
+              <a:ext uri="{FF2B5EF4-FFF2-40B4-BE49-F238E27FC236}">
+                <a16:creationId xmlns:a16="http://schemas.microsoft.com/office/drawing/2014/main" id="{8F64FDE8-2EE4-55CB-4029-D047B65AE309}"/>
+              </a:ext>
+            </a:extLst>
+          </p:cNvPr>
+          <p:cNvSpPr txBox="1"/>
+          <p:nvPr/>
+        </p:nvSpPr>
+        <p:spPr>
+          <a:xfrm>
+            <a:off x="1082841" y="32759357"/>
+            <a:ext cx="23031367" cy="2246769"/>
+          </a:xfrm>
+          <a:prstGeom prst="rect">
+            <a:avLst/>
+          </a:prstGeom>
+          <a:noFill/>
+        </p:spPr>
+        <p:txBody>
+          <a:bodyPr wrap="square" rtlCol="0">
+            <a:spAutoFit/>
+          </a:bodyPr>
+          <a:lstStyle/>
+          <a:p>
+            <a:r>
+              <a:rPr lang="hu-HU" sz="2000" b="1" dirty="0"/>
+              <a:t>Források / </a:t>
+            </a:r>
+            <a:r>
+              <a:rPr lang="hu-HU" sz="2000" b="1" dirty="0" err="1"/>
+              <a:t>Sources</a:t>
+            </a:r>
+            <a:endParaRPr lang="hu-HU" sz="2000" b="1" dirty="0"/>
+          </a:p>
+          <a:p>
+            <a:pPr marL="342900" indent="-342900">
+              <a:buFontTx/>
+              <a:buChar char="-"/>
+            </a:pPr>
+            <a:r>
+              <a:rPr lang="hu-HU" sz="2000" dirty="0"/>
+              <a:t>Projekt kód </a:t>
+            </a:r>
+            <a:r>
+              <a:rPr lang="hu-HU" sz="2000" dirty="0" err="1"/>
+              <a:t>repozitóriuma</a:t>
+            </a:r>
+            <a:r>
+              <a:rPr lang="hu-HU" sz="2000" dirty="0"/>
+              <a:t> - </a:t>
+            </a:r>
+            <a:r>
+              <a:rPr lang="en-US" sz="2000" dirty="0"/>
+              <a:t>GitHub: </a:t>
+            </a:r>
+            <a:r>
+              <a:rPr lang="en-US" sz="2000" dirty="0">
+                <a:hlinkClick r:id="rId8"/>
+              </a:rPr>
+              <a:t>https://github.com/ARTidas/DroneDefibrillator</a:t>
+            </a:r>
+            <a:r>
+              <a:rPr lang="hu-HU" sz="2000" dirty="0"/>
+              <a:t> </a:t>
+            </a:r>
+          </a:p>
+          <a:p>
+            <a:pPr marL="342900" indent="-342900">
+              <a:buFontTx/>
+              <a:buChar char="-"/>
+            </a:pPr>
+            <a:r>
+              <a:rPr lang="hu-HU" sz="2000" dirty="0"/>
+              <a:t>Helységlista - KSH:  </a:t>
+            </a:r>
+            <a:r>
+              <a:rPr lang="hu-HU" sz="2000" dirty="0">
+                <a:hlinkClick r:id="rId9"/>
+              </a:rPr>
+              <a:t>https://www.ksh.hu/apps/hntr.egyeb?p_lang=HU&amp;p_sablon=LETOLTES</a:t>
+            </a:r>
+            <a:endParaRPr lang="hu-HU" sz="2000" dirty="0"/>
+          </a:p>
+          <a:p>
+            <a:pPr marL="342900" indent="-342900">
+              <a:buFontTx/>
+              <a:buChar char="-"/>
+            </a:pPr>
+            <a:r>
+              <a:rPr lang="nl-NL" sz="2000" dirty="0"/>
+              <a:t>Drónok - DataVerse: </a:t>
+            </a:r>
+            <a:r>
+              <a:rPr lang="nl-NL" sz="2000" dirty="0">
+                <a:hlinkClick r:id="rId10"/>
+              </a:rPr>
+              <a:t>https://dataverse.no/dataset.xhtml?persistentId=doi:10.18710/L41IGQ</a:t>
+            </a:r>
+            <a:r>
+              <a:rPr lang="hu-HU" sz="2000" dirty="0"/>
+              <a:t> </a:t>
+            </a:r>
+          </a:p>
+          <a:p>
+            <a:pPr marL="342900" indent="-342900">
+              <a:buFontTx/>
+              <a:buChar char="-"/>
+            </a:pPr>
+            <a:r>
+              <a:rPr lang="hu-HU" sz="2000" dirty="0"/>
+              <a:t>Népsűrűség ellenőrzése: HDX - </a:t>
+            </a:r>
+            <a:r>
+              <a:rPr lang="hu-HU" sz="2000" dirty="0">
+                <a:hlinkClick r:id="rId11"/>
+              </a:rPr>
+              <a:t>https://data.humdata.org/dataset/worldpop-population-counts-2015-2030-hun</a:t>
+            </a:r>
+            <a:endParaRPr lang="hu-HU" sz="2000" dirty="0"/>
+          </a:p>
+          <a:p>
+            <a:pPr marL="342900" indent="-342900">
+              <a:buFontTx/>
+              <a:buChar char="-"/>
+            </a:pPr>
+            <a:r>
+              <a:rPr lang="pt-BR" sz="2000" dirty="0"/>
+              <a:t>Geográfiai koordináták - Nominatim API: </a:t>
+            </a:r>
+            <a:r>
+              <a:rPr lang="pt-BR" sz="2000" dirty="0">
+                <a:hlinkClick r:id="rId12"/>
+              </a:rPr>
+              <a:t>https://nominatim.org/</a:t>
+            </a:r>
+            <a:r>
+              <a:rPr lang="hu-HU" sz="2000" dirty="0"/>
+              <a:t> </a:t>
+            </a:r>
+          </a:p>
+          <a:p>
+            <a:pPr marL="342900" indent="-342900">
+              <a:buFontTx/>
+              <a:buChar char="-"/>
+            </a:pPr>
+            <a:r>
+              <a:rPr lang="hu-HU" sz="2000" dirty="0"/>
+              <a:t>Éves esetek száma – EgészségKalauz.hu : </a:t>
+            </a:r>
+            <a:r>
+              <a:rPr lang="hu-HU" sz="2000" dirty="0">
+                <a:hlinkClick r:id="rId13"/>
+              </a:rPr>
+              <a:t>https://www.egeszsegkalauz.hu/extra-ajanlo/a-magyar-emberek-fele-sziv-es-errendszeri-betegseg-miatt-veszti-eletet-hogyan/cz5jnx4</a:t>
+            </a:r>
+            <a:r>
+              <a:rPr lang="hu-HU" sz="2000" dirty="0"/>
+              <a:t> </a:t>
+            </a:r>
+            <a:endParaRPr lang="nl-NL" sz="2000" dirty="0"/>
           </a:p>
         </p:txBody>
       </p:sp>

</xml_diff>

<commit_message>
Created poster variants: HungarianEnglish, Hungarian, English
</commit_message>
<xml_diff>
--- a/Conference/DroneDefibrillator_202610041823.pptx
+++ b/Conference/DroneDefibrillator_202610041823.pptx
@@ -6,10 +6,12 @@
     <p:sldMasterId id="2147483672" r:id="rId2"/>
   </p:sldMasterIdLst>
   <p:notesMasterIdLst>
-    <p:notesMasterId r:id="rId4"/>
+    <p:notesMasterId r:id="rId6"/>
   </p:notesMasterIdLst>
   <p:sldIdLst>
     <p:sldId id="256" r:id="rId3"/>
+    <p:sldId id="257" r:id="rId4"/>
+    <p:sldId id="258" r:id="rId5"/>
   </p:sldIdLst>
   <p:sldSz cx="25199975" cy="35999738"/>
   <p:notesSz cx="6858000" cy="9144000"/>
@@ -111,7 +113,7 @@
   <p:extLst>
     <p:ext uri="{EFAFB233-063F-42B5-8137-9DF3F51BA10A}">
       <p15:sldGuideLst xmlns:p15="http://schemas.microsoft.com/office/powerpoint/2012/main">
-        <p15:guide id="1" orient="horz" pos="11338" userDrawn="1">
+        <p15:guide id="1" orient="horz" pos="11361" userDrawn="1">
           <p15:clr>
             <a:srgbClr val="A4A3A4"/>
           </p15:clr>
@@ -6824,7 +6826,7 @@
         <p:spPr>
           <a:xfrm>
             <a:off x="1082843" y="6108085"/>
-            <a:ext cx="7916778" cy="5032147"/>
+            <a:ext cx="7916778" cy="4662815"/>
           </a:xfrm>
           <a:prstGeom prst="rect">
             <a:avLst/>
@@ -6842,9 +6844,6 @@
               <a:rPr lang="hu-HU" sz="4500" b="1" dirty="0"/>
               <a:t>Absztrakt</a:t>
             </a:r>
-          </a:p>
-          <a:p>
-            <a:pPr algn="just"/>
             <a:endParaRPr lang="hu-HU" sz="2400" dirty="0"/>
           </a:p>
           <a:p>
@@ -6904,7 +6903,7 @@
         <p:spPr>
           <a:xfrm>
             <a:off x="16200355" y="6108085"/>
-            <a:ext cx="7916778" cy="5032147"/>
+            <a:ext cx="7916778" cy="4662815"/>
           </a:xfrm>
           <a:prstGeom prst="rect">
             <a:avLst/>
@@ -6922,10 +6921,6 @@
               <a:rPr lang="hu-HU" sz="4500" b="1" dirty="0" err="1"/>
               <a:t>Abstract</a:t>
             </a:r>
-            <a:endParaRPr lang="hu-HU" sz="4500" b="1" dirty="0"/>
-          </a:p>
-          <a:p>
-            <a:pPr algn="just"/>
             <a:endParaRPr lang="hu-HU" sz="2400" dirty="0"/>
           </a:p>
           <a:p>
@@ -8102,7 +8097,7 @@
         <p:spPr>
           <a:xfrm>
             <a:off x="1082843" y="11398702"/>
-            <a:ext cx="5386952" cy="8910131"/>
+            <a:ext cx="5386952" cy="8540800"/>
           </a:xfrm>
           <a:prstGeom prst="rect">
             <a:avLst/>
@@ -8120,9 +8115,6 @@
               <a:rPr lang="hu-HU" sz="4500" b="1" dirty="0"/>
               <a:t>Módszertan</a:t>
             </a:r>
-          </a:p>
-          <a:p>
-            <a:pPr algn="just"/>
             <a:endParaRPr lang="hu-HU" sz="2400" dirty="0"/>
           </a:p>
           <a:p>
@@ -8290,7 +8282,7 @@
         <p:spPr>
           <a:xfrm>
             <a:off x="18730180" y="11416712"/>
-            <a:ext cx="5386952" cy="8633133"/>
+            <a:ext cx="5386952" cy="8263801"/>
           </a:xfrm>
           <a:prstGeom prst="rect">
             <a:avLst/>
@@ -8308,9 +8300,6 @@
               <a:rPr lang="hu-HU" sz="4500" b="1" dirty="0" err="1"/>
               <a:t>Methodology</a:t>
             </a:r>
-            <a:endParaRPr lang="hu-HU" sz="4500" b="1" dirty="0"/>
-          </a:p>
-          <a:p>
             <a:endParaRPr lang="hu-HU" sz="2400" dirty="0"/>
           </a:p>
           <a:p>
@@ -9980,6 +9969,3712 @@
     <p:extLst>
       <p:ext uri="{BB962C8B-B14F-4D97-AF65-F5344CB8AC3E}">
         <p14:creationId xmlns:p14="http://schemas.microsoft.com/office/powerpoint/2010/main" val="3278358569"/>
+      </p:ext>
+    </p:extLst>
+  </p:cSld>
+  <p:clrMapOvr>
+    <a:masterClrMapping/>
+  </p:clrMapOvr>
+</p:sld>
+</file>
+
+<file path=ppt/slides/slide2.xml><?xml version="1.0" encoding="utf-8"?>
+<p:sld xmlns:a="http://schemas.openxmlformats.org/drawingml/2006/main" xmlns:r="http://schemas.openxmlformats.org/officeDocument/2006/relationships" xmlns:p="http://schemas.openxmlformats.org/presentationml/2006/main">
+  <p:cSld>
+    <p:spTree>
+      <p:nvGrpSpPr>
+        <p:cNvPr id="1" name="">
+          <a:extLst>
+            <a:ext uri="{FF2B5EF4-FFF2-40B4-BE49-F238E27FC236}">
+              <a16:creationId xmlns:a16="http://schemas.microsoft.com/office/drawing/2014/main" id="{3339435A-0547-3248-8EFC-E07B8F443B86}"/>
+            </a:ext>
+          </a:extLst>
+        </p:cNvPr>
+        <p:cNvGrpSpPr/>
+        <p:nvPr/>
+      </p:nvGrpSpPr>
+      <p:grpSpPr>
+        <a:xfrm>
+          <a:off x="0" y="0"/>
+          <a:ext cx="0" cy="0"/>
+          <a:chOff x="0" y="0"/>
+          <a:chExt cx="0" cy="0"/>
+        </a:xfrm>
+      </p:grpSpPr>
+      <p:sp>
+        <p:nvSpPr>
+          <p:cNvPr id="8" name="TextBox 7">
+            <a:extLst>
+              <a:ext uri="{FF2B5EF4-FFF2-40B4-BE49-F238E27FC236}">
+                <a16:creationId xmlns:a16="http://schemas.microsoft.com/office/drawing/2014/main" id="{AE86C3B2-7B33-C813-0ECA-7B41A02F79E2}"/>
+              </a:ext>
+            </a:extLst>
+          </p:cNvPr>
+          <p:cNvSpPr txBox="1"/>
+          <p:nvPr/>
+        </p:nvSpPr>
+        <p:spPr>
+          <a:xfrm>
+            <a:off x="1082842" y="1469110"/>
+            <a:ext cx="23031365" cy="2092881"/>
+          </a:xfrm>
+          <a:prstGeom prst="rect">
+            <a:avLst/>
+          </a:prstGeom>
+          <a:noFill/>
+        </p:spPr>
+        <p:txBody>
+          <a:bodyPr wrap="square" rtlCol="0">
+            <a:spAutoFit/>
+          </a:bodyPr>
+          <a:lstStyle/>
+          <a:p>
+            <a:pPr algn="ctr"/>
+            <a:r>
+              <a:rPr lang="hu-HU" sz="6500" b="1" dirty="0"/>
+              <a:t>Automata külső </a:t>
+            </a:r>
+            <a:r>
+              <a:rPr lang="hu-HU" sz="6500" b="1" dirty="0" err="1"/>
+              <a:t>defibrillátor</a:t>
+            </a:r>
+            <a:r>
+              <a:rPr lang="hu-HU" sz="6500" b="1" dirty="0"/>
+              <a:t> (AED) kiszállítása drónnal:</a:t>
+            </a:r>
+            <a:br>
+              <a:rPr lang="hu-HU" sz="6500" dirty="0"/>
+            </a:br>
+            <a:r>
+              <a:rPr lang="hu-HU" sz="6500" dirty="0"/>
+              <a:t>Térinformatikai megoldások és operációkutatási optimalizálás</a:t>
+            </a:r>
+          </a:p>
+        </p:txBody>
+      </p:sp>
+      <p:pic>
+        <p:nvPicPr>
+          <p:cNvPr id="17" name="Content Placeholder 13">
+            <a:extLst>
+              <a:ext uri="{FF2B5EF4-FFF2-40B4-BE49-F238E27FC236}">
+                <a16:creationId xmlns:a16="http://schemas.microsoft.com/office/drawing/2014/main" id="{3533E786-2B31-289B-7FA8-21021DA65D95}"/>
+              </a:ext>
+            </a:extLst>
+          </p:cNvPr>
+          <p:cNvPicPr>
+            <a:picLocks noChangeAspect="1"/>
+          </p:cNvPicPr>
+          <p:nvPr/>
+        </p:nvPicPr>
+        <p:blipFill>
+          <a:blip r:embed="rId2">
+            <a:extLst>
+              <a:ext uri="{28A0092B-C50C-407E-A947-70E740481C1C}">
+                <a14:useLocalDpi xmlns:a14="http://schemas.microsoft.com/office/drawing/2010/main" val="0"/>
+              </a:ext>
+            </a:extLst>
+          </a:blip>
+          <a:stretch>
+            <a:fillRect/>
+          </a:stretch>
+        </p:blipFill>
+        <p:spPr>
+          <a:xfrm>
+            <a:off x="16623286" y="6846053"/>
+            <a:ext cx="4294181" cy="4294181"/>
+          </a:xfrm>
+          <a:prstGeom prst="rect">
+            <a:avLst/>
+          </a:prstGeom>
+        </p:spPr>
+      </p:pic>
+      <p:sp>
+        <p:nvSpPr>
+          <p:cNvPr id="25" name="TextBox 24">
+            <a:extLst>
+              <a:ext uri="{FF2B5EF4-FFF2-40B4-BE49-F238E27FC236}">
+                <a16:creationId xmlns:a16="http://schemas.microsoft.com/office/drawing/2014/main" id="{F924E9CD-5112-0C69-AADB-A83235352C5D}"/>
+              </a:ext>
+            </a:extLst>
+          </p:cNvPr>
+          <p:cNvSpPr txBox="1"/>
+          <p:nvPr/>
+        </p:nvSpPr>
+        <p:spPr>
+          <a:xfrm>
+            <a:off x="1082841" y="6505609"/>
+            <a:ext cx="11517146" cy="5816977"/>
+          </a:xfrm>
+          <a:prstGeom prst="rect">
+            <a:avLst/>
+          </a:prstGeom>
+          <a:noFill/>
+        </p:spPr>
+        <p:txBody>
+          <a:bodyPr wrap="square" rtlCol="0">
+            <a:spAutoFit/>
+          </a:bodyPr>
+          <a:lstStyle/>
+          <a:p>
+            <a:pPr algn="ctr"/>
+            <a:r>
+              <a:rPr lang="hu-HU" sz="6000" b="1" dirty="0"/>
+              <a:t>Absztrakt</a:t>
+            </a:r>
+            <a:endParaRPr lang="hu-HU" sz="2400" dirty="0"/>
+          </a:p>
+          <a:p>
+            <a:pPr algn="just"/>
+            <a:r>
+              <a:rPr lang="hu-HU" sz="2400" dirty="0"/>
+              <a:t>A szívmegállás túlélési esélyének növelésére ígéretes megoldás az automata külső </a:t>
+            </a:r>
+            <a:r>
+              <a:rPr lang="hu-HU" sz="2400" dirty="0" err="1"/>
+              <a:t>defibrillátorok</a:t>
+            </a:r>
+            <a:r>
+              <a:rPr lang="hu-HU" sz="2400" dirty="0"/>
+              <a:t> (AED) drónokkal történő kiszállítása. Kutatásunk célja megtervezni egy Magyarországot lefedő, AED-ket szállító drónhálózatot. Ehhez készítettünk egy adatbázist, mely tartalmazza a postacímeket, a népesség számát és geográfiai koordinátáit. A megfelelő drón és ezáltal a hatósugár (és hasznos teher) kiválasztása három paraméter mentén lett súlyozva többszempontú döntéselemzéssel (MCDA): Végsebesség (0.5), hatótáv (0.2), súly (inverz 0.2) és hasznos teher (0.1). A demográfiai eloszlást </a:t>
+            </a:r>
+            <a:r>
+              <a:rPr lang="hu-HU" sz="2400" dirty="0" err="1"/>
+              <a:t>izoband</a:t>
+            </a:r>
+            <a:r>
+              <a:rPr lang="hu-HU" sz="2400" dirty="0"/>
+              <a:t> vonalak képében jelenítettük meg és </a:t>
+            </a:r>
+            <a:r>
+              <a:rPr lang="hu-HU" sz="2400" dirty="0" err="1"/>
+              <a:t>GeoTiff</a:t>
+            </a:r>
+            <a:r>
+              <a:rPr lang="hu-HU" sz="2400" dirty="0"/>
+              <a:t> fájl segítségével ellenőriztük az eredményünket szemrevételezéssel. A drónbázisok elhelyezését egy kapacitáskorlátos mohó algoritmus optimalizálta az éves hazai esetszámok (63 000 / év) térbeli eloszlása alapján. Interaktív webes szimulációnk igazolja: 30 km-es hatótávú drónok alkalmazásával kevesebb, mint 50 bázis is elegendő az országos AED igények legalább 95%-</a:t>
+            </a:r>
+            <a:r>
+              <a:rPr lang="hu-HU" sz="2400" dirty="0" err="1"/>
+              <a:t>ának</a:t>
+            </a:r>
+            <a:r>
+              <a:rPr lang="hu-HU" sz="2400" dirty="0"/>
+              <a:t> lefedésére.</a:t>
+            </a:r>
+          </a:p>
+        </p:txBody>
+      </p:sp>
+      <p:sp>
+        <p:nvSpPr>
+          <p:cNvPr id="41" name="TextBox 40">
+            <a:extLst>
+              <a:ext uri="{FF2B5EF4-FFF2-40B4-BE49-F238E27FC236}">
+                <a16:creationId xmlns:a16="http://schemas.microsoft.com/office/drawing/2014/main" id="{33969C6F-A949-F4CA-2370-2EE5E6852C51}"/>
+              </a:ext>
+            </a:extLst>
+          </p:cNvPr>
+          <p:cNvSpPr txBox="1"/>
+          <p:nvPr/>
+        </p:nvSpPr>
+        <p:spPr>
+          <a:xfrm>
+            <a:off x="16623287" y="4907061"/>
+            <a:ext cx="4294181" cy="1938992"/>
+          </a:xfrm>
+          <a:prstGeom prst="rect">
+            <a:avLst/>
+          </a:prstGeom>
+          <a:noFill/>
+        </p:spPr>
+        <p:txBody>
+          <a:bodyPr wrap="square" rtlCol="0">
+            <a:spAutoFit/>
+          </a:bodyPr>
+          <a:lstStyle/>
+          <a:p>
+            <a:pPr algn="ctr"/>
+            <a:r>
+              <a:rPr lang="hu-HU" sz="6000" b="1" dirty="0"/>
+              <a:t>Interaktív szimuláció!</a:t>
+            </a:r>
+          </a:p>
+        </p:txBody>
+      </p:sp>
+      <p:sp>
+        <p:nvSpPr>
+          <p:cNvPr id="45" name="TextBox 44">
+            <a:extLst>
+              <a:ext uri="{FF2B5EF4-FFF2-40B4-BE49-F238E27FC236}">
+                <a16:creationId xmlns:a16="http://schemas.microsoft.com/office/drawing/2014/main" id="{92C08AE5-00D6-5B2F-DFC8-E36AF423709A}"/>
+              </a:ext>
+            </a:extLst>
+          </p:cNvPr>
+          <p:cNvSpPr txBox="1"/>
+          <p:nvPr/>
+        </p:nvSpPr>
+        <p:spPr>
+          <a:xfrm>
+            <a:off x="1116939" y="3955328"/>
+            <a:ext cx="11359640" cy="1708160"/>
+          </a:xfrm>
+          <a:prstGeom prst="rect">
+            <a:avLst/>
+          </a:prstGeom>
+          <a:noFill/>
+        </p:spPr>
+        <p:txBody>
+          <a:bodyPr wrap="square" rtlCol="0">
+            <a:spAutoFit/>
+          </a:bodyPr>
+          <a:lstStyle/>
+          <a:p>
+            <a:r>
+              <a:rPr lang="hu-HU" sz="3500" dirty="0"/>
+              <a:t>Szerzők:		Veres Zoltán, Dr. Takács István</a:t>
+            </a:r>
+            <a:br>
+              <a:rPr lang="hu-HU" sz="3500" dirty="0"/>
+            </a:br>
+            <a:r>
+              <a:rPr lang="hu-HU" sz="3500" dirty="0"/>
+              <a:t>					Tokaj-Hegyalja Egyetem, Lorántffy Intézet</a:t>
+            </a:r>
+            <a:br>
+              <a:rPr lang="hu-HU" sz="3500" dirty="0"/>
+            </a:br>
+            <a:r>
+              <a:rPr lang="hu-HU" sz="3500" dirty="0"/>
+              <a:t>E-mail:			veres.zoltan@unithe.hu</a:t>
+            </a:r>
+          </a:p>
+        </p:txBody>
+      </p:sp>
+      <p:pic>
+        <p:nvPicPr>
+          <p:cNvPr id="49" name="Picture 48">
+            <a:extLst>
+              <a:ext uri="{FF2B5EF4-FFF2-40B4-BE49-F238E27FC236}">
+                <a16:creationId xmlns:a16="http://schemas.microsoft.com/office/drawing/2014/main" id="{E80B2CA1-4659-3F10-50C1-DC6B158AF272}"/>
+              </a:ext>
+            </a:extLst>
+          </p:cNvPr>
+          <p:cNvPicPr>
+            <a:picLocks noChangeAspect="1"/>
+          </p:cNvPicPr>
+          <p:nvPr/>
+        </p:nvPicPr>
+        <p:blipFill>
+          <a:blip r:embed="rId3"/>
+          <a:stretch>
+            <a:fillRect/>
+          </a:stretch>
+        </p:blipFill>
+        <p:spPr>
+          <a:xfrm>
+            <a:off x="12757491" y="12990628"/>
+            <a:ext cx="12260386" cy="7621064"/>
+          </a:xfrm>
+          <a:prstGeom prst="rect">
+            <a:avLst/>
+          </a:prstGeom>
+        </p:spPr>
+      </p:pic>
+      <p:sp>
+        <p:nvSpPr>
+          <p:cNvPr id="51" name="TextBox 50">
+            <a:extLst>
+              <a:ext uri="{FF2B5EF4-FFF2-40B4-BE49-F238E27FC236}">
+                <a16:creationId xmlns:a16="http://schemas.microsoft.com/office/drawing/2014/main" id="{A176176F-8A64-841A-3561-E27950942685}"/>
+              </a:ext>
+            </a:extLst>
+          </p:cNvPr>
+          <p:cNvSpPr txBox="1"/>
+          <p:nvPr/>
+        </p:nvSpPr>
+        <p:spPr>
+          <a:xfrm>
+            <a:off x="1116939" y="12986206"/>
+            <a:ext cx="11359640" cy="7294305"/>
+          </a:xfrm>
+          <a:prstGeom prst="rect">
+            <a:avLst/>
+          </a:prstGeom>
+          <a:noFill/>
+        </p:spPr>
+        <p:txBody>
+          <a:bodyPr wrap="square" rtlCol="0">
+            <a:spAutoFit/>
+          </a:bodyPr>
+          <a:lstStyle/>
+          <a:p>
+            <a:pPr algn="ctr"/>
+            <a:r>
+              <a:rPr lang="hu-HU" sz="6000" b="1" dirty="0" err="1"/>
+              <a:t>Methodology</a:t>
+            </a:r>
+            <a:endParaRPr lang="hu-HU" sz="3200" dirty="0"/>
+          </a:p>
+          <a:p>
+            <a:pPr algn="just"/>
+            <a:r>
+              <a:rPr lang="hu-HU" sz="2400" dirty="0"/>
+              <a:t>The </a:t>
+            </a:r>
+            <a:r>
+              <a:rPr lang="hu-HU" sz="2400" dirty="0" err="1"/>
+              <a:t>research</a:t>
+            </a:r>
+            <a:r>
+              <a:rPr lang="hu-HU" sz="2400" dirty="0"/>
+              <a:t> is </a:t>
+            </a:r>
+            <a:r>
+              <a:rPr lang="hu-HU" sz="2400" dirty="0" err="1"/>
+              <a:t>based</a:t>
+            </a:r>
+            <a:r>
+              <a:rPr lang="hu-HU" sz="2400" dirty="0"/>
+              <a:t> </a:t>
+            </a:r>
+            <a:r>
+              <a:rPr lang="hu-HU" sz="2400" dirty="0" err="1"/>
+              <a:t>on</a:t>
+            </a:r>
+            <a:r>
+              <a:rPr lang="hu-HU" sz="2400" dirty="0"/>
+              <a:t> a </a:t>
+            </a:r>
+            <a:r>
+              <a:rPr lang="hu-HU" sz="2400" dirty="0" err="1"/>
+              <a:t>data-driven</a:t>
+            </a:r>
+            <a:r>
+              <a:rPr lang="hu-HU" sz="2400" dirty="0"/>
+              <a:t> </a:t>
+            </a:r>
+            <a:r>
+              <a:rPr lang="hu-HU" sz="2400" dirty="0" err="1"/>
+              <a:t>framework</a:t>
+            </a:r>
+            <a:r>
+              <a:rPr lang="hu-HU" sz="2400" dirty="0"/>
+              <a:t>, </a:t>
+            </a:r>
+            <a:r>
+              <a:rPr lang="hu-HU" sz="2400" dirty="0" err="1"/>
+              <a:t>which</a:t>
+            </a:r>
+            <a:r>
+              <a:rPr lang="hu-HU" sz="2400" dirty="0"/>
+              <a:t> </a:t>
+            </a:r>
+            <a:r>
+              <a:rPr lang="hu-HU" sz="2400" dirty="0" err="1"/>
+              <a:t>combines</a:t>
+            </a:r>
+            <a:r>
+              <a:rPr lang="hu-HU" sz="2400" dirty="0"/>
+              <a:t> </a:t>
+            </a:r>
+            <a:r>
+              <a:rPr lang="hu-HU" sz="2400" dirty="0" err="1"/>
+              <a:t>geographical</a:t>
+            </a:r>
+            <a:r>
+              <a:rPr lang="hu-HU" sz="2400" dirty="0"/>
+              <a:t> </a:t>
+            </a:r>
+            <a:r>
+              <a:rPr lang="hu-HU" sz="2400" dirty="0" err="1"/>
+              <a:t>information</a:t>
+            </a:r>
+            <a:r>
+              <a:rPr lang="hu-HU" sz="2400" dirty="0"/>
+              <a:t> </a:t>
+            </a:r>
+            <a:r>
+              <a:rPr lang="hu-HU" sz="2400" dirty="0" err="1"/>
+              <a:t>systems</a:t>
+            </a:r>
+            <a:r>
+              <a:rPr lang="hu-HU" sz="2400" dirty="0"/>
+              <a:t> (GIS) in </a:t>
+            </a:r>
+            <a:r>
+              <a:rPr lang="hu-HU" sz="2400" dirty="0" err="1"/>
+              <a:t>four</a:t>
+            </a:r>
+            <a:r>
+              <a:rPr lang="hu-HU" sz="2400" dirty="0"/>
+              <a:t> </a:t>
+            </a:r>
+            <a:r>
+              <a:rPr lang="hu-HU" sz="2400" dirty="0" err="1"/>
+              <a:t>steps</a:t>
+            </a:r>
+            <a:r>
+              <a:rPr lang="hu-HU" sz="2400" dirty="0"/>
+              <a:t>:</a:t>
+            </a:r>
+            <a:br>
+              <a:rPr lang="hu-HU" sz="2400" dirty="0"/>
+            </a:br>
+            <a:r>
+              <a:rPr lang="hu-HU" sz="2400" b="1" dirty="0"/>
+              <a:t>GIS </a:t>
+            </a:r>
+            <a:r>
+              <a:rPr lang="hu-HU" sz="2400" b="1" dirty="0" err="1"/>
+              <a:t>modeling</a:t>
+            </a:r>
+            <a:r>
+              <a:rPr lang="hu-HU" sz="2400" b="1" dirty="0"/>
+              <a:t>:</a:t>
+            </a:r>
+            <a:r>
+              <a:rPr lang="hu-HU" sz="2400" dirty="0"/>
+              <a:t> </a:t>
+            </a:r>
+            <a:r>
+              <a:rPr lang="hu-HU" sz="2400" dirty="0" err="1"/>
+              <a:t>We</a:t>
+            </a:r>
+            <a:r>
+              <a:rPr lang="hu-HU" sz="2400" dirty="0"/>
+              <a:t> </a:t>
+            </a:r>
+            <a:r>
+              <a:rPr lang="hu-HU" sz="2400" dirty="0" err="1"/>
+              <a:t>determined</a:t>
+            </a:r>
+            <a:r>
+              <a:rPr lang="hu-HU" sz="2400" dirty="0"/>
+              <a:t> </a:t>
+            </a:r>
+            <a:r>
+              <a:rPr lang="hu-HU" sz="2400" dirty="0" err="1"/>
+              <a:t>the</a:t>
+            </a:r>
+            <a:r>
+              <a:rPr lang="hu-HU" sz="2400" dirty="0"/>
+              <a:t> </a:t>
+            </a:r>
+            <a:r>
+              <a:rPr lang="hu-HU" sz="2400" dirty="0" err="1"/>
+              <a:t>distribution</a:t>
+            </a:r>
+            <a:r>
+              <a:rPr lang="hu-HU" sz="2400" dirty="0"/>
+              <a:t> of </a:t>
+            </a:r>
+            <a:r>
+              <a:rPr lang="hu-HU" sz="2400" dirty="0" err="1"/>
+              <a:t>Hungary's</a:t>
+            </a:r>
+            <a:r>
+              <a:rPr lang="hu-HU" sz="2400" dirty="0"/>
+              <a:t> </a:t>
+            </a:r>
+            <a:r>
+              <a:rPr lang="hu-HU" sz="2400" dirty="0" err="1"/>
+              <a:t>population</a:t>
+            </a:r>
+            <a:r>
+              <a:rPr lang="hu-HU" sz="2400" dirty="0"/>
+              <a:t> </a:t>
+            </a:r>
+            <a:r>
+              <a:rPr lang="hu-HU" sz="2400" dirty="0" err="1"/>
+              <a:t>based</a:t>
+            </a:r>
+            <a:r>
+              <a:rPr lang="hu-HU" sz="2400" dirty="0"/>
+              <a:t> </a:t>
+            </a:r>
+            <a:r>
+              <a:rPr lang="hu-HU" sz="2400" dirty="0" err="1"/>
+              <a:t>on</a:t>
+            </a:r>
+            <a:r>
+              <a:rPr lang="hu-HU" sz="2400" dirty="0"/>
+              <a:t> </a:t>
+            </a:r>
+            <a:r>
+              <a:rPr lang="hu-HU" sz="2400" dirty="0" err="1"/>
+              <a:t>postal-code</a:t>
+            </a:r>
+            <a:r>
+              <a:rPr lang="hu-HU" sz="2400" dirty="0"/>
+              <a:t> </a:t>
+            </a:r>
+            <a:r>
+              <a:rPr lang="hu-HU" sz="2400" dirty="0" err="1"/>
+              <a:t>level</a:t>
+            </a:r>
+            <a:r>
+              <a:rPr lang="hu-HU" sz="2400" dirty="0"/>
+              <a:t> </a:t>
+            </a:r>
+            <a:r>
+              <a:rPr lang="hu-HU" sz="2400" dirty="0" err="1"/>
+              <a:t>demographic</a:t>
+            </a:r>
+            <a:r>
+              <a:rPr lang="hu-HU" sz="2400" dirty="0"/>
+              <a:t> </a:t>
+            </a:r>
+            <a:r>
+              <a:rPr lang="hu-HU" sz="2400" dirty="0" err="1"/>
+              <a:t>data</a:t>
+            </a:r>
+            <a:r>
+              <a:rPr lang="hu-HU" sz="2400" dirty="0"/>
+              <a:t>, </a:t>
+            </a:r>
+            <a:r>
+              <a:rPr lang="hu-HU" sz="2400" dirty="0" err="1"/>
+              <a:t>which</a:t>
+            </a:r>
+            <a:r>
+              <a:rPr lang="hu-HU" sz="2400" dirty="0"/>
+              <a:t> </a:t>
+            </a:r>
+            <a:r>
+              <a:rPr lang="hu-HU" sz="2400" dirty="0" err="1"/>
+              <a:t>were</a:t>
+            </a:r>
+            <a:r>
+              <a:rPr lang="hu-HU" sz="2400" dirty="0"/>
+              <a:t> </a:t>
+            </a:r>
+            <a:r>
+              <a:rPr lang="hu-HU" sz="2400" dirty="0" err="1"/>
+              <a:t>visualised</a:t>
+            </a:r>
+            <a:r>
+              <a:rPr lang="hu-HU" sz="2400" dirty="0"/>
+              <a:t> </a:t>
+            </a:r>
+            <a:r>
+              <a:rPr lang="hu-HU" sz="2400" dirty="0" err="1"/>
+              <a:t>with</a:t>
+            </a:r>
+            <a:r>
+              <a:rPr lang="hu-HU" sz="2400" dirty="0"/>
+              <a:t> </a:t>
+            </a:r>
+            <a:r>
+              <a:rPr lang="hu-HU" sz="2400" dirty="0" err="1"/>
+              <a:t>isobands</a:t>
+            </a:r>
+            <a:r>
+              <a:rPr lang="hu-HU" sz="2400" dirty="0"/>
+              <a:t>. The </a:t>
+            </a:r>
+            <a:r>
+              <a:rPr lang="hu-HU" sz="2400" dirty="0" err="1"/>
+              <a:t>model</a:t>
+            </a:r>
+            <a:r>
+              <a:rPr lang="hu-HU" sz="2400" dirty="0"/>
+              <a:t> </a:t>
+            </a:r>
+            <a:r>
+              <a:rPr lang="hu-HU" sz="2400" dirty="0" err="1"/>
+              <a:t>was</a:t>
+            </a:r>
+            <a:r>
+              <a:rPr lang="hu-HU" sz="2400" dirty="0"/>
+              <a:t> </a:t>
+            </a:r>
+            <a:r>
+              <a:rPr lang="hu-HU" sz="2400" dirty="0" err="1"/>
+              <a:t>visually</a:t>
+            </a:r>
+            <a:r>
+              <a:rPr lang="hu-HU" sz="2400" dirty="0"/>
+              <a:t> </a:t>
+            </a:r>
+            <a:r>
+              <a:rPr lang="hu-HU" sz="2400" dirty="0" err="1"/>
+              <a:t>cross-referenced</a:t>
+            </a:r>
+            <a:r>
+              <a:rPr lang="hu-HU" sz="2400" dirty="0"/>
+              <a:t> </a:t>
+            </a:r>
+            <a:r>
+              <a:rPr lang="hu-HU" sz="2400" dirty="0" err="1"/>
+              <a:t>with</a:t>
+            </a:r>
+            <a:r>
+              <a:rPr lang="hu-HU" sz="2400" dirty="0"/>
+              <a:t> a 100 </a:t>
+            </a:r>
+            <a:r>
+              <a:rPr lang="hu-HU" sz="2400" dirty="0" err="1"/>
+              <a:t>meter</a:t>
+            </a:r>
+            <a:r>
+              <a:rPr lang="hu-HU" sz="2400" dirty="0"/>
+              <a:t> </a:t>
+            </a:r>
+            <a:r>
+              <a:rPr lang="hu-HU" sz="2400" dirty="0" err="1"/>
+              <a:t>resolution</a:t>
+            </a:r>
+            <a:r>
+              <a:rPr lang="hu-HU" sz="2400" dirty="0"/>
+              <a:t> </a:t>
+            </a:r>
+            <a:r>
+              <a:rPr lang="hu-HU" sz="2400" dirty="0" err="1"/>
+              <a:t>raster</a:t>
+            </a:r>
+            <a:r>
+              <a:rPr lang="hu-HU" sz="2400" dirty="0"/>
+              <a:t> (</a:t>
+            </a:r>
+            <a:r>
+              <a:rPr lang="hu-HU" sz="2400" dirty="0" err="1"/>
+              <a:t>GeoTiff</a:t>
+            </a:r>
+            <a:r>
+              <a:rPr lang="hu-HU" sz="2400" dirty="0"/>
+              <a:t>) </a:t>
+            </a:r>
+            <a:r>
+              <a:rPr lang="hu-HU" sz="2400" dirty="0" err="1"/>
+              <a:t>population</a:t>
+            </a:r>
+            <a:r>
+              <a:rPr lang="hu-HU" sz="2400" dirty="0"/>
+              <a:t> </a:t>
+            </a:r>
+            <a:r>
+              <a:rPr lang="hu-HU" sz="2400" dirty="0" err="1"/>
+              <a:t>density</a:t>
+            </a:r>
+            <a:r>
+              <a:rPr lang="hu-HU" sz="2400" dirty="0"/>
+              <a:t> </a:t>
+            </a:r>
+            <a:r>
+              <a:rPr lang="hu-HU" sz="2400" dirty="0" err="1"/>
+              <a:t>dataset</a:t>
+            </a:r>
+            <a:r>
+              <a:rPr lang="hu-HU" sz="2400" dirty="0"/>
+              <a:t>.</a:t>
+            </a:r>
+            <a:br>
+              <a:rPr lang="hu-HU" sz="2400" dirty="0"/>
+            </a:br>
+            <a:r>
+              <a:rPr lang="hu-HU" sz="2400" b="1" dirty="0"/>
+              <a:t>Multi-</a:t>
+            </a:r>
+            <a:r>
+              <a:rPr lang="hu-HU" sz="2400" b="1" dirty="0" err="1"/>
+              <a:t>criteria</a:t>
+            </a:r>
+            <a:r>
+              <a:rPr lang="hu-HU" sz="2400" b="1" dirty="0"/>
+              <a:t> decision </a:t>
+            </a:r>
+            <a:r>
+              <a:rPr lang="hu-HU" sz="2400" b="1" dirty="0" err="1"/>
+              <a:t>analysis</a:t>
+            </a:r>
+            <a:r>
+              <a:rPr lang="hu-HU" sz="2400" b="1" dirty="0"/>
+              <a:t> (MCDA):</a:t>
+            </a:r>
+            <a:r>
+              <a:rPr lang="hu-HU" sz="2400" dirty="0"/>
+              <a:t> </a:t>
+            </a:r>
+            <a:r>
+              <a:rPr lang="hu-HU" sz="2400" dirty="0" err="1"/>
+              <a:t>We</a:t>
+            </a:r>
+            <a:r>
+              <a:rPr lang="hu-HU" sz="2400" dirty="0"/>
+              <a:t> </a:t>
+            </a:r>
+            <a:r>
+              <a:rPr lang="hu-HU" sz="2400" dirty="0" err="1"/>
+              <a:t>selected</a:t>
+            </a:r>
+            <a:r>
+              <a:rPr lang="hu-HU" sz="2400" dirty="0"/>
+              <a:t> </a:t>
+            </a:r>
+            <a:r>
+              <a:rPr lang="hu-HU" sz="2400" dirty="0" err="1"/>
+              <a:t>the</a:t>
+            </a:r>
+            <a:r>
+              <a:rPr lang="hu-HU" sz="2400" dirty="0"/>
+              <a:t> most </a:t>
+            </a:r>
+            <a:r>
+              <a:rPr lang="hu-HU" sz="2400" dirty="0" err="1"/>
+              <a:t>suitable</a:t>
+            </a:r>
+            <a:r>
+              <a:rPr lang="hu-HU" sz="2400" dirty="0"/>
+              <a:t> </a:t>
+            </a:r>
+            <a:r>
+              <a:rPr lang="hu-HU" sz="2400" dirty="0" err="1"/>
+              <a:t>drone</a:t>
+            </a:r>
+            <a:r>
+              <a:rPr lang="hu-HU" sz="2400" dirty="0"/>
+              <a:t> </a:t>
+            </a:r>
+            <a:r>
+              <a:rPr lang="hu-HU" sz="2400" dirty="0" err="1"/>
+              <a:t>for</a:t>
+            </a:r>
+            <a:r>
+              <a:rPr lang="hu-HU" sz="2400" dirty="0"/>
+              <a:t> </a:t>
+            </a:r>
+            <a:r>
+              <a:rPr lang="hu-HU" sz="2400" dirty="0" err="1"/>
+              <a:t>the</a:t>
+            </a:r>
+            <a:r>
+              <a:rPr lang="hu-HU" sz="2400" dirty="0"/>
+              <a:t> </a:t>
+            </a:r>
+            <a:r>
+              <a:rPr lang="hu-HU" sz="2400" dirty="0" err="1"/>
+              <a:t>task</a:t>
+            </a:r>
+            <a:r>
+              <a:rPr lang="hu-HU" sz="2400" dirty="0"/>
+              <a:t> </a:t>
+            </a:r>
+            <a:r>
+              <a:rPr lang="hu-HU" sz="2400" dirty="0" err="1"/>
+              <a:t>using</a:t>
+            </a:r>
+            <a:r>
+              <a:rPr lang="hu-HU" sz="2400" dirty="0"/>
+              <a:t> a </a:t>
+            </a:r>
+            <a:r>
+              <a:rPr lang="hu-HU" sz="2400" dirty="0" err="1"/>
+              <a:t>weighted</a:t>
+            </a:r>
+            <a:r>
+              <a:rPr lang="hu-HU" sz="2400" dirty="0"/>
+              <a:t> </a:t>
+            </a:r>
+            <a:r>
+              <a:rPr lang="hu-HU" sz="2400" dirty="0" err="1"/>
+              <a:t>scoring</a:t>
+            </a:r>
+            <a:r>
+              <a:rPr lang="hu-HU" sz="2400" dirty="0"/>
+              <a:t> </a:t>
+            </a:r>
+            <a:r>
+              <a:rPr lang="hu-HU" sz="2400" dirty="0" err="1"/>
+              <a:t>system</a:t>
+            </a:r>
+            <a:r>
+              <a:rPr lang="hu-HU" sz="2400" dirty="0"/>
+              <a:t>. The </a:t>
+            </a:r>
+            <a:r>
+              <a:rPr lang="hu-HU" sz="2400" dirty="0" err="1"/>
+              <a:t>model</a:t>
+            </a:r>
+            <a:r>
+              <a:rPr lang="hu-HU" sz="2400" dirty="0"/>
+              <a:t> </a:t>
+            </a:r>
+            <a:r>
+              <a:rPr lang="hu-HU" sz="2400" dirty="0" err="1"/>
+              <a:t>considered</a:t>
+            </a:r>
+            <a:r>
+              <a:rPr lang="hu-HU" sz="2400" dirty="0"/>
+              <a:t> top </a:t>
+            </a:r>
+            <a:r>
+              <a:rPr lang="hu-HU" sz="2400" dirty="0" err="1"/>
+              <a:t>speed</a:t>
+            </a:r>
+            <a:r>
+              <a:rPr lang="hu-HU" sz="2400" dirty="0"/>
+              <a:t> (50%), </a:t>
+            </a:r>
+            <a:r>
+              <a:rPr lang="hu-HU" sz="2400" dirty="0" err="1"/>
+              <a:t>operational</a:t>
+            </a:r>
+            <a:r>
+              <a:rPr lang="hu-HU" sz="2400" dirty="0"/>
+              <a:t> </a:t>
+            </a:r>
+            <a:r>
+              <a:rPr lang="hu-HU" sz="2400" dirty="0" err="1"/>
+              <a:t>range</a:t>
+            </a:r>
+            <a:r>
+              <a:rPr lang="hu-HU" sz="2400" dirty="0"/>
+              <a:t> (20%), maximum </a:t>
+            </a:r>
+            <a:r>
+              <a:rPr lang="hu-HU" sz="2400" dirty="0" err="1"/>
+              <a:t>take-off</a:t>
+            </a:r>
+            <a:r>
+              <a:rPr lang="hu-HU" sz="2400" dirty="0"/>
+              <a:t> </a:t>
+            </a:r>
+            <a:r>
+              <a:rPr lang="hu-HU" sz="2400" dirty="0" err="1"/>
+              <a:t>weight</a:t>
+            </a:r>
+            <a:r>
+              <a:rPr lang="hu-HU" sz="2400" dirty="0"/>
+              <a:t> – </a:t>
+            </a:r>
+            <a:r>
+              <a:rPr lang="hu-HU" sz="2400" dirty="0" err="1"/>
+              <a:t>safety</a:t>
+            </a:r>
+            <a:r>
+              <a:rPr lang="hu-HU" sz="2400" dirty="0"/>
+              <a:t> and </a:t>
+            </a:r>
+            <a:r>
+              <a:rPr lang="hu-HU" sz="2400" dirty="0" err="1"/>
+              <a:t>handling</a:t>
+            </a:r>
+            <a:r>
+              <a:rPr lang="hu-HU" sz="2400" dirty="0"/>
+              <a:t> – (</a:t>
+            </a:r>
+            <a:r>
+              <a:rPr lang="hu-HU" sz="2400" dirty="0" err="1"/>
+              <a:t>inverted</a:t>
+            </a:r>
+            <a:r>
+              <a:rPr lang="hu-HU" sz="2400" dirty="0"/>
+              <a:t> 20%), and </a:t>
+            </a:r>
+            <a:r>
+              <a:rPr lang="hu-HU" sz="2400" dirty="0" err="1"/>
+              <a:t>payload</a:t>
+            </a:r>
+            <a:r>
+              <a:rPr lang="hu-HU" sz="2400" dirty="0"/>
+              <a:t> </a:t>
+            </a:r>
+            <a:r>
+              <a:rPr lang="hu-HU" sz="2400" dirty="0" err="1"/>
+              <a:t>capacity</a:t>
+            </a:r>
+            <a:r>
+              <a:rPr lang="hu-HU" sz="2400" dirty="0"/>
+              <a:t> (10%).</a:t>
+            </a:r>
+            <a:br>
+              <a:rPr lang="hu-HU" sz="2400" dirty="0"/>
+            </a:br>
+            <a:r>
+              <a:rPr lang="hu-HU" sz="2400" b="1" dirty="0"/>
+              <a:t>Network </a:t>
+            </a:r>
+            <a:r>
+              <a:rPr lang="hu-HU" sz="2400" b="1" dirty="0" err="1"/>
+              <a:t>optimisation</a:t>
+            </a:r>
+            <a:r>
+              <a:rPr lang="hu-HU" sz="2400" b="1" dirty="0"/>
+              <a:t>:</a:t>
+            </a:r>
+            <a:r>
+              <a:rPr lang="hu-HU" sz="2400" dirty="0"/>
+              <a:t> </a:t>
+            </a:r>
+            <a:r>
+              <a:rPr lang="hu-HU" sz="2400" dirty="0" err="1"/>
+              <a:t>We</a:t>
+            </a:r>
+            <a:r>
+              <a:rPr lang="hu-HU" sz="2400" dirty="0"/>
+              <a:t> </a:t>
+            </a:r>
+            <a:r>
+              <a:rPr lang="hu-HU" sz="2400" dirty="0" err="1"/>
+              <a:t>approached</a:t>
+            </a:r>
+            <a:r>
+              <a:rPr lang="hu-HU" sz="2400" dirty="0"/>
+              <a:t> </a:t>
+            </a:r>
+            <a:r>
+              <a:rPr lang="hu-HU" sz="2400" dirty="0" err="1"/>
+              <a:t>the</a:t>
+            </a:r>
+            <a:r>
+              <a:rPr lang="hu-HU" sz="2400" dirty="0"/>
+              <a:t> </a:t>
+            </a:r>
+            <a:r>
+              <a:rPr lang="hu-HU" sz="2400" dirty="0" err="1"/>
+              <a:t>placement</a:t>
+            </a:r>
+            <a:r>
+              <a:rPr lang="hu-HU" sz="2400" dirty="0"/>
+              <a:t> of </a:t>
+            </a:r>
+            <a:r>
+              <a:rPr lang="hu-HU" sz="2400" dirty="0" err="1"/>
+              <a:t>the</a:t>
+            </a:r>
+            <a:r>
+              <a:rPr lang="hu-HU" sz="2400" dirty="0"/>
+              <a:t> </a:t>
+            </a:r>
+            <a:r>
+              <a:rPr lang="hu-HU" sz="2400" dirty="0" err="1"/>
+              <a:t>drone</a:t>
+            </a:r>
+            <a:r>
+              <a:rPr lang="hu-HU" sz="2400" dirty="0"/>
+              <a:t> </a:t>
+            </a:r>
+            <a:r>
+              <a:rPr lang="hu-HU" sz="2400" dirty="0" err="1"/>
+              <a:t>bases</a:t>
+            </a:r>
+            <a:r>
+              <a:rPr lang="hu-HU" sz="2400" dirty="0"/>
+              <a:t> </a:t>
+            </a:r>
+            <a:r>
+              <a:rPr lang="hu-HU" sz="2400" dirty="0" err="1"/>
+              <a:t>as</a:t>
+            </a:r>
+            <a:r>
+              <a:rPr lang="hu-HU" sz="2400" dirty="0"/>
+              <a:t> a </a:t>
+            </a:r>
+            <a:r>
+              <a:rPr lang="hu-HU" sz="2400" dirty="0" err="1"/>
+              <a:t>facility</a:t>
+            </a:r>
+            <a:r>
+              <a:rPr lang="hu-HU" sz="2400" dirty="0"/>
+              <a:t> </a:t>
+            </a:r>
+            <a:r>
+              <a:rPr lang="hu-HU" sz="2400" dirty="0" err="1"/>
+              <a:t>location</a:t>
+            </a:r>
+            <a:r>
+              <a:rPr lang="hu-HU" sz="2400" dirty="0"/>
+              <a:t> </a:t>
+            </a:r>
+            <a:r>
+              <a:rPr lang="hu-HU" sz="2400" dirty="0" err="1"/>
+              <a:t>problem</a:t>
+            </a:r>
+            <a:r>
+              <a:rPr lang="hu-HU" sz="2400" dirty="0"/>
+              <a:t>. </a:t>
+            </a:r>
+            <a:r>
+              <a:rPr lang="hu-HU" sz="2400" dirty="0" err="1"/>
+              <a:t>By</a:t>
+            </a:r>
+            <a:r>
+              <a:rPr lang="hu-HU" sz="2400" dirty="0"/>
+              <a:t> </a:t>
+            </a:r>
+            <a:r>
+              <a:rPr lang="hu-HU" sz="2400" dirty="0" err="1"/>
+              <a:t>utilising</a:t>
+            </a:r>
+            <a:r>
+              <a:rPr lang="hu-HU" sz="2400" dirty="0"/>
+              <a:t> a </a:t>
+            </a:r>
+            <a:r>
+              <a:rPr lang="hu-HU" sz="2400" dirty="0" err="1"/>
+              <a:t>capacity-restrained</a:t>
+            </a:r>
+            <a:r>
+              <a:rPr lang="hu-HU" sz="2400" dirty="0"/>
+              <a:t> </a:t>
+            </a:r>
+            <a:r>
+              <a:rPr lang="hu-HU" sz="2400" dirty="0" err="1"/>
+              <a:t>greedy</a:t>
+            </a:r>
+            <a:r>
+              <a:rPr lang="hu-HU" sz="2400" dirty="0"/>
+              <a:t> </a:t>
+            </a:r>
+            <a:r>
+              <a:rPr lang="hu-HU" sz="2400" dirty="0" err="1"/>
+              <a:t>algorithm</a:t>
+            </a:r>
+            <a:r>
+              <a:rPr lang="hu-HU" sz="2400" dirty="0"/>
+              <a:t> </a:t>
+            </a:r>
+            <a:r>
+              <a:rPr lang="hu-HU" sz="2400" dirty="0" err="1"/>
+              <a:t>to</a:t>
+            </a:r>
+            <a:r>
+              <a:rPr lang="hu-HU" sz="2400" dirty="0"/>
+              <a:t> minimise </a:t>
+            </a:r>
+            <a:r>
+              <a:rPr lang="hu-HU" sz="2400" dirty="0" err="1"/>
+              <a:t>the</a:t>
+            </a:r>
+            <a:r>
+              <a:rPr lang="hu-HU" sz="2400" dirty="0"/>
+              <a:t> </a:t>
+            </a:r>
+            <a:r>
+              <a:rPr lang="hu-HU" sz="2400" dirty="0" err="1"/>
+              <a:t>number</a:t>
+            </a:r>
+            <a:r>
+              <a:rPr lang="hu-HU" sz="2400" dirty="0"/>
+              <a:t> of </a:t>
+            </a:r>
+            <a:r>
+              <a:rPr lang="hu-HU" sz="2400" dirty="0" err="1"/>
+              <a:t>required</a:t>
+            </a:r>
+            <a:r>
+              <a:rPr lang="hu-HU" sz="2400" dirty="0"/>
+              <a:t> </a:t>
+            </a:r>
+            <a:r>
+              <a:rPr lang="hu-HU" sz="2400" dirty="0" err="1"/>
+              <a:t>drone</a:t>
+            </a:r>
+            <a:r>
+              <a:rPr lang="hu-HU" sz="2400" dirty="0"/>
+              <a:t> </a:t>
+            </a:r>
+            <a:r>
+              <a:rPr lang="hu-HU" sz="2400" dirty="0" err="1"/>
+              <a:t>bases</a:t>
+            </a:r>
+            <a:r>
+              <a:rPr lang="hu-HU" sz="2400" dirty="0"/>
+              <a:t>, </a:t>
+            </a:r>
+            <a:r>
+              <a:rPr lang="hu-HU" sz="2400" dirty="0" err="1"/>
+              <a:t>based</a:t>
+            </a:r>
+            <a:r>
+              <a:rPr lang="hu-HU" sz="2400" dirty="0"/>
+              <a:t> </a:t>
+            </a:r>
+            <a:r>
+              <a:rPr lang="hu-HU" sz="2400" dirty="0" err="1"/>
+              <a:t>on</a:t>
+            </a:r>
+            <a:r>
+              <a:rPr lang="hu-HU" sz="2400" dirty="0"/>
+              <a:t> </a:t>
+            </a:r>
+            <a:r>
+              <a:rPr lang="hu-HU" sz="2400" dirty="0" err="1"/>
+              <a:t>the</a:t>
+            </a:r>
+            <a:r>
+              <a:rPr lang="hu-HU" sz="2400" dirty="0"/>
+              <a:t> </a:t>
+            </a:r>
+            <a:r>
+              <a:rPr lang="hu-HU" sz="2400" dirty="0" err="1"/>
+              <a:t>population-weighted</a:t>
+            </a:r>
+            <a:r>
+              <a:rPr lang="hu-HU" sz="2400" dirty="0"/>
+              <a:t> </a:t>
+            </a:r>
+            <a:r>
+              <a:rPr lang="hu-HU" sz="2400" dirty="0" err="1"/>
+              <a:t>distribution</a:t>
+            </a:r>
+            <a:r>
+              <a:rPr lang="hu-HU" sz="2400" dirty="0"/>
+              <a:t> of an </a:t>
+            </a:r>
+            <a:r>
+              <a:rPr lang="hu-HU" sz="2400" dirty="0" err="1"/>
+              <a:t>estimated</a:t>
+            </a:r>
+            <a:r>
+              <a:rPr lang="hu-HU" sz="2400" dirty="0"/>
+              <a:t> 63 000 </a:t>
+            </a:r>
+            <a:r>
+              <a:rPr lang="hu-HU" sz="2400" dirty="0" err="1"/>
+              <a:t>annual</a:t>
+            </a:r>
+            <a:r>
+              <a:rPr lang="hu-HU" sz="2400" dirty="0"/>
+              <a:t> </a:t>
+            </a:r>
+            <a:r>
+              <a:rPr lang="hu-HU" sz="2400" dirty="0" err="1"/>
+              <a:t>domestic</a:t>
+            </a:r>
+            <a:r>
+              <a:rPr lang="hu-HU" sz="2400" dirty="0"/>
+              <a:t> </a:t>
+            </a:r>
+            <a:r>
+              <a:rPr lang="hu-HU" sz="2400" dirty="0" err="1"/>
+              <a:t>cases</a:t>
+            </a:r>
+            <a:r>
+              <a:rPr lang="hu-HU" sz="2400" dirty="0"/>
+              <a:t>.</a:t>
+            </a:r>
+            <a:br>
+              <a:rPr lang="hu-HU" sz="2400" dirty="0"/>
+            </a:br>
+            <a:r>
+              <a:rPr lang="hu-HU" sz="2400" b="1" dirty="0" err="1"/>
+              <a:t>Interactive</a:t>
+            </a:r>
+            <a:r>
+              <a:rPr lang="hu-HU" sz="2400" b="1" dirty="0"/>
+              <a:t> </a:t>
+            </a:r>
+            <a:r>
+              <a:rPr lang="hu-HU" sz="2400" b="1" dirty="0" err="1"/>
+              <a:t>simulation</a:t>
+            </a:r>
+            <a:r>
+              <a:rPr lang="hu-HU" sz="2400" b="1" dirty="0"/>
+              <a:t>:</a:t>
+            </a:r>
+            <a:r>
+              <a:rPr lang="hu-HU" sz="2400" dirty="0"/>
+              <a:t> </a:t>
+            </a:r>
+            <a:r>
+              <a:rPr lang="hu-HU" sz="2400" dirty="0" err="1"/>
+              <a:t>We</a:t>
+            </a:r>
+            <a:r>
+              <a:rPr lang="hu-HU" sz="2400" dirty="0"/>
+              <a:t> </a:t>
+            </a:r>
+            <a:r>
+              <a:rPr lang="hu-HU" sz="2400" dirty="0" err="1"/>
+              <a:t>developed</a:t>
+            </a:r>
+            <a:r>
+              <a:rPr lang="hu-HU" sz="2400" dirty="0"/>
+              <a:t> a web-</a:t>
+            </a:r>
+            <a:r>
+              <a:rPr lang="hu-HU" sz="2400" dirty="0" err="1"/>
+              <a:t>based</a:t>
+            </a:r>
+            <a:r>
+              <a:rPr lang="hu-HU" sz="2400" dirty="0"/>
+              <a:t> map-</a:t>
+            </a:r>
+            <a:r>
+              <a:rPr lang="hu-HU" sz="2400" dirty="0" err="1"/>
+              <a:t>driven</a:t>
+            </a:r>
+            <a:r>
+              <a:rPr lang="hu-HU" sz="2400" dirty="0"/>
+              <a:t> decision </a:t>
+            </a:r>
+            <a:r>
+              <a:rPr lang="hu-HU" sz="2400" dirty="0" err="1"/>
+              <a:t>support</a:t>
+            </a:r>
+            <a:r>
+              <a:rPr lang="hu-HU" sz="2400" dirty="0"/>
+              <a:t> </a:t>
+            </a:r>
+            <a:r>
+              <a:rPr lang="hu-HU" sz="2400" dirty="0" err="1"/>
+              <a:t>system</a:t>
+            </a:r>
+            <a:r>
+              <a:rPr lang="hu-HU" sz="2400" dirty="0"/>
+              <a:t> (</a:t>
+            </a:r>
+            <a:r>
+              <a:rPr lang="hu-HU" sz="2400" dirty="0" err="1"/>
+              <a:t>dashboard</a:t>
+            </a:r>
+            <a:r>
+              <a:rPr lang="hu-HU" sz="2400" dirty="0"/>
+              <a:t>) </a:t>
+            </a:r>
+            <a:r>
+              <a:rPr lang="hu-HU" sz="2400" dirty="0" err="1"/>
+              <a:t>that</a:t>
+            </a:r>
+            <a:r>
+              <a:rPr lang="hu-HU" sz="2400" dirty="0"/>
+              <a:t> </a:t>
+            </a:r>
+            <a:r>
+              <a:rPr lang="hu-HU" sz="2400" dirty="0" err="1"/>
+              <a:t>recalculates</a:t>
+            </a:r>
+            <a:r>
+              <a:rPr lang="hu-HU" sz="2400" dirty="0"/>
+              <a:t> </a:t>
+            </a:r>
+            <a:r>
+              <a:rPr lang="hu-HU" sz="2400" dirty="0" err="1"/>
+              <a:t>network</a:t>
+            </a:r>
+            <a:r>
+              <a:rPr lang="hu-HU" sz="2400" dirty="0"/>
+              <a:t> </a:t>
+            </a:r>
+            <a:r>
+              <a:rPr lang="hu-HU" sz="2400" dirty="0" err="1"/>
+              <a:t>coverage</a:t>
+            </a:r>
+            <a:r>
+              <a:rPr lang="hu-HU" sz="2400" dirty="0"/>
+              <a:t> in </a:t>
+            </a:r>
+            <a:r>
+              <a:rPr lang="hu-HU" sz="2400" dirty="0" err="1"/>
+              <a:t>real-time</a:t>
+            </a:r>
+            <a:r>
+              <a:rPr lang="hu-HU" sz="2400" dirty="0"/>
+              <a:t> </a:t>
+            </a:r>
+            <a:r>
+              <a:rPr lang="hu-HU" sz="2400" dirty="0" err="1"/>
+              <a:t>based</a:t>
+            </a:r>
+            <a:r>
+              <a:rPr lang="hu-HU" sz="2400" dirty="0"/>
+              <a:t> </a:t>
+            </a:r>
+            <a:r>
+              <a:rPr lang="hu-HU" sz="2400" dirty="0" err="1"/>
+              <a:t>on</a:t>
+            </a:r>
+            <a:r>
+              <a:rPr lang="hu-HU" sz="2400" dirty="0"/>
+              <a:t> input </a:t>
+            </a:r>
+            <a:r>
+              <a:rPr lang="hu-HU" sz="2400" dirty="0" err="1"/>
+              <a:t>parameters</a:t>
+            </a:r>
+            <a:r>
+              <a:rPr lang="hu-HU" sz="2400" dirty="0"/>
+              <a:t> (</a:t>
+            </a:r>
+            <a:r>
+              <a:rPr lang="hu-HU" sz="2400" dirty="0" err="1"/>
+              <a:t>operational</a:t>
+            </a:r>
+            <a:r>
+              <a:rPr lang="hu-HU" sz="2400" dirty="0"/>
+              <a:t> </a:t>
+            </a:r>
+            <a:r>
+              <a:rPr lang="hu-HU" sz="2400" dirty="0" err="1"/>
+              <a:t>range</a:t>
+            </a:r>
+            <a:r>
+              <a:rPr lang="hu-HU" sz="2400" dirty="0"/>
+              <a:t>, </a:t>
+            </a:r>
+            <a:r>
+              <a:rPr lang="hu-HU" sz="2400" dirty="0" err="1"/>
+              <a:t>drone</a:t>
+            </a:r>
+            <a:r>
+              <a:rPr lang="hu-HU" sz="2400" dirty="0"/>
+              <a:t> and </a:t>
+            </a:r>
+            <a:r>
+              <a:rPr lang="hu-HU" sz="2400" dirty="0" err="1"/>
+              <a:t>base</a:t>
+            </a:r>
+            <a:r>
+              <a:rPr lang="hu-HU" sz="2400" dirty="0"/>
+              <a:t> </a:t>
+            </a:r>
+            <a:r>
+              <a:rPr lang="hu-HU" sz="2400" dirty="0" err="1"/>
+              <a:t>capacity</a:t>
+            </a:r>
+            <a:r>
+              <a:rPr lang="hu-HU" sz="2400" dirty="0"/>
+              <a:t>).</a:t>
+            </a:r>
+            <a:endParaRPr lang="hu-HU" sz="3200" dirty="0"/>
+          </a:p>
+        </p:txBody>
+      </p:sp>
+      <p:pic>
+        <p:nvPicPr>
+          <p:cNvPr id="59" name="Picture 58">
+            <a:extLst>
+              <a:ext uri="{FF2B5EF4-FFF2-40B4-BE49-F238E27FC236}">
+                <a16:creationId xmlns:a16="http://schemas.microsoft.com/office/drawing/2014/main" id="{E48F066E-0F17-615B-D6A6-AFBC63F06296}"/>
+              </a:ext>
+            </a:extLst>
+          </p:cNvPr>
+          <p:cNvPicPr>
+            <a:picLocks noChangeAspect="1"/>
+          </p:cNvPicPr>
+          <p:nvPr/>
+        </p:nvPicPr>
+        <p:blipFill>
+          <a:blip r:embed="rId4">
+            <a:extLst>
+              <a:ext uri="{28A0092B-C50C-407E-A947-70E740481C1C}">
+                <a14:useLocalDpi xmlns:a14="http://schemas.microsoft.com/office/drawing/2010/main" val="0"/>
+              </a:ext>
+            </a:extLst>
+          </a:blip>
+          <a:srcRect/>
+          <a:stretch/>
+        </p:blipFill>
+        <p:spPr>
+          <a:xfrm>
+            <a:off x="8692650" y="21873794"/>
+            <a:ext cx="7712241" cy="4507081"/>
+          </a:xfrm>
+          <a:prstGeom prst="rect">
+            <a:avLst/>
+          </a:prstGeom>
+        </p:spPr>
+      </p:pic>
+      <p:pic>
+        <p:nvPicPr>
+          <p:cNvPr id="61" name="Picture 60">
+            <a:extLst>
+              <a:ext uri="{FF2B5EF4-FFF2-40B4-BE49-F238E27FC236}">
+                <a16:creationId xmlns:a16="http://schemas.microsoft.com/office/drawing/2014/main" id="{59E92E89-FC26-84FE-24BE-25F12A13DCCC}"/>
+              </a:ext>
+            </a:extLst>
+          </p:cNvPr>
+          <p:cNvPicPr>
+            <a:picLocks noChangeAspect="1"/>
+          </p:cNvPicPr>
+          <p:nvPr/>
+        </p:nvPicPr>
+        <p:blipFill>
+          <a:blip r:embed="rId5">
+            <a:extLst>
+              <a:ext uri="{28A0092B-C50C-407E-A947-70E740481C1C}">
+                <a14:useLocalDpi xmlns:a14="http://schemas.microsoft.com/office/drawing/2010/main" val="0"/>
+              </a:ext>
+            </a:extLst>
+          </a:blip>
+          <a:stretch>
+            <a:fillRect/>
+          </a:stretch>
+        </p:blipFill>
+        <p:spPr>
+          <a:xfrm>
+            <a:off x="16404891" y="21857380"/>
+            <a:ext cx="7712242" cy="4539910"/>
+          </a:xfrm>
+          <a:prstGeom prst="rect">
+            <a:avLst/>
+          </a:prstGeom>
+        </p:spPr>
+      </p:pic>
+      <p:pic>
+        <p:nvPicPr>
+          <p:cNvPr id="63" name="Picture 62">
+            <a:extLst>
+              <a:ext uri="{FF2B5EF4-FFF2-40B4-BE49-F238E27FC236}">
+                <a16:creationId xmlns:a16="http://schemas.microsoft.com/office/drawing/2014/main" id="{CEA30715-1E11-B9B8-5A41-AC110737F100}"/>
+              </a:ext>
+            </a:extLst>
+          </p:cNvPr>
+          <p:cNvPicPr>
+            <a:picLocks noChangeAspect="1"/>
+          </p:cNvPicPr>
+          <p:nvPr/>
+        </p:nvPicPr>
+        <p:blipFill>
+          <a:blip r:embed="rId6">
+            <a:extLst>
+              <a:ext uri="{28A0092B-C50C-407E-A947-70E740481C1C}">
+                <a14:useLocalDpi xmlns:a14="http://schemas.microsoft.com/office/drawing/2010/main" val="0"/>
+              </a:ext>
+            </a:extLst>
+          </a:blip>
+          <a:stretch>
+            <a:fillRect/>
+          </a:stretch>
+        </p:blipFill>
+        <p:spPr>
+          <a:xfrm>
+            <a:off x="1082843" y="21848883"/>
+            <a:ext cx="7609807" cy="4519021"/>
+          </a:xfrm>
+          <a:prstGeom prst="rect">
+            <a:avLst/>
+          </a:prstGeom>
+        </p:spPr>
+      </p:pic>
+      <p:sp>
+        <p:nvSpPr>
+          <p:cNvPr id="66" name="TextBox 65">
+            <a:extLst>
+              <a:ext uri="{FF2B5EF4-FFF2-40B4-BE49-F238E27FC236}">
+                <a16:creationId xmlns:a16="http://schemas.microsoft.com/office/drawing/2014/main" id="{630CA5FC-FC7F-A8B8-8DB3-2C3513C3744D}"/>
+              </a:ext>
+            </a:extLst>
+          </p:cNvPr>
+          <p:cNvSpPr txBox="1"/>
+          <p:nvPr/>
+        </p:nvSpPr>
+        <p:spPr>
+          <a:xfrm>
+            <a:off x="1092328" y="20914973"/>
+            <a:ext cx="11359640" cy="1015663"/>
+          </a:xfrm>
+          <a:prstGeom prst="rect">
+            <a:avLst/>
+          </a:prstGeom>
+          <a:noFill/>
+        </p:spPr>
+        <p:txBody>
+          <a:bodyPr wrap="square" rtlCol="0">
+            <a:spAutoFit/>
+          </a:bodyPr>
+          <a:lstStyle/>
+          <a:p>
+            <a:pPr algn="ctr"/>
+            <a:r>
+              <a:rPr lang="hu-HU" sz="6000" b="1" dirty="0"/>
+              <a:t>Eredmények</a:t>
+            </a:r>
+          </a:p>
+        </p:txBody>
+      </p:sp>
+      <p:pic>
+        <p:nvPicPr>
+          <p:cNvPr id="78" name="Picture 77">
+            <a:extLst>
+              <a:ext uri="{FF2B5EF4-FFF2-40B4-BE49-F238E27FC236}">
+                <a16:creationId xmlns:a16="http://schemas.microsoft.com/office/drawing/2014/main" id="{6C48E0E2-A2BC-34A0-DDDB-2ED489EF24A3}"/>
+              </a:ext>
+            </a:extLst>
+          </p:cNvPr>
+          <p:cNvPicPr>
+            <a:picLocks noChangeAspect="1"/>
+          </p:cNvPicPr>
+          <p:nvPr/>
+        </p:nvPicPr>
+        <p:blipFill>
+          <a:blip r:embed="rId7">
+            <a:extLst>
+              <a:ext uri="{28A0092B-C50C-407E-A947-70E740481C1C}">
+                <a14:useLocalDpi xmlns:a14="http://schemas.microsoft.com/office/drawing/2010/main" val="0"/>
+              </a:ext>
+            </a:extLst>
+          </a:blip>
+          <a:stretch>
+            <a:fillRect/>
+          </a:stretch>
+        </p:blipFill>
+        <p:spPr>
+          <a:xfrm>
+            <a:off x="13574159" y="27392911"/>
+            <a:ext cx="10627050" cy="6376230"/>
+          </a:xfrm>
+          <a:prstGeom prst="rect">
+            <a:avLst/>
+          </a:prstGeom>
+        </p:spPr>
+      </p:pic>
+      <p:sp>
+        <p:nvSpPr>
+          <p:cNvPr id="80" name="TextBox 79">
+            <a:extLst>
+              <a:ext uri="{FF2B5EF4-FFF2-40B4-BE49-F238E27FC236}">
+                <a16:creationId xmlns:a16="http://schemas.microsoft.com/office/drawing/2014/main" id="{481C802E-FC1F-63E9-0791-29A9CD73939F}"/>
+              </a:ext>
+            </a:extLst>
+          </p:cNvPr>
+          <p:cNvSpPr txBox="1"/>
+          <p:nvPr/>
+        </p:nvSpPr>
+        <p:spPr>
+          <a:xfrm>
+            <a:off x="1070642" y="27381778"/>
+            <a:ext cx="11381326" cy="4708981"/>
+          </a:xfrm>
+          <a:prstGeom prst="rect">
+            <a:avLst/>
+          </a:prstGeom>
+          <a:noFill/>
+        </p:spPr>
+        <p:txBody>
+          <a:bodyPr wrap="square" rtlCol="0">
+            <a:spAutoFit/>
+          </a:bodyPr>
+          <a:lstStyle/>
+          <a:p>
+            <a:pPr algn="ctr"/>
+            <a:r>
+              <a:rPr lang="hu-HU" sz="6000" b="1" dirty="0"/>
+              <a:t>Konklúzió</a:t>
+            </a:r>
+          </a:p>
+          <a:p>
+            <a:pPr algn="just"/>
+            <a:r>
+              <a:rPr lang="hu-HU" sz="2400" b="1" dirty="0"/>
+              <a:t>Matematikai optimum:</a:t>
+            </a:r>
+            <a:r>
+              <a:rPr lang="hu-HU" sz="2400" dirty="0"/>
+              <a:t> A hálózat optimalizálása során a csökkenő hozadék (</a:t>
+            </a:r>
+            <a:r>
+              <a:rPr lang="hu-HU" sz="2400" dirty="0" err="1"/>
+              <a:t>diminishing</a:t>
+            </a:r>
+            <a:r>
+              <a:rPr lang="hu-HU" sz="2400" dirty="0"/>
+              <a:t> </a:t>
+            </a:r>
+            <a:r>
+              <a:rPr lang="hu-HU" sz="2400" dirty="0" err="1"/>
+              <a:t>returns</a:t>
+            </a:r>
+            <a:r>
+              <a:rPr lang="hu-HU" sz="2400" dirty="0"/>
+              <a:t>) elve egyértelműen megmutatkozik a drónok hatótávja és a bázisigény között. Az ideális egyensúlyi pont (</a:t>
+            </a:r>
+            <a:r>
+              <a:rPr lang="hu-HU" sz="2400" dirty="0" err="1"/>
+              <a:t>sweet</a:t>
+            </a:r>
+            <a:r>
+              <a:rPr lang="hu-HU" sz="2400" dirty="0"/>
+              <a:t> spot) 16 km-es hatótávolságnál található.</a:t>
+            </a:r>
+          </a:p>
+          <a:p>
+            <a:pPr algn="just"/>
+            <a:r>
+              <a:rPr lang="hu-HU" sz="2400" b="1" dirty="0"/>
+              <a:t>Infrastrukturális igény: </a:t>
+            </a:r>
+            <a:r>
+              <a:rPr lang="hu-HU" sz="2400" dirty="0"/>
+              <a:t>Ezen a ponton az országos AED-kereslet 95%-os lefedéséhez 140 drónbázis telepítése szükséges.</a:t>
+            </a:r>
+          </a:p>
+          <a:p>
+            <a:pPr algn="just"/>
+            <a:r>
+              <a:rPr lang="hu-HU" sz="2400" b="1" dirty="0"/>
+              <a:t>Végső verdikt: </a:t>
+            </a:r>
+            <a:r>
+              <a:rPr lang="hu-HU" sz="2400" dirty="0"/>
+              <a:t>Egy kisméretű, 16-20 km hatósugarú eszközökre (pl. VTOL technológiára) épülő, </a:t>
+            </a:r>
+            <a:r>
+              <a:rPr lang="hu-HU" sz="2400" dirty="0" err="1"/>
+              <a:t>adatvezérelt</a:t>
+            </a:r>
+            <a:r>
+              <a:rPr lang="hu-HU" sz="2400" dirty="0"/>
+              <a:t> drónhálózat </a:t>
+            </a:r>
+            <a:r>
+              <a:rPr lang="hu-HU" sz="2400" dirty="0" err="1"/>
+              <a:t>logisztikailag</a:t>
+            </a:r>
+            <a:r>
+              <a:rPr lang="hu-HU" sz="2400" dirty="0"/>
+              <a:t> és pénzügyileg is kivitelezhető, reális megoldást nyújthat a hazai hirtelen szívmegállások túlélési láncának forradalmasítására.</a:t>
+            </a:r>
+          </a:p>
+        </p:txBody>
+      </p:sp>
+      <p:sp>
+        <p:nvSpPr>
+          <p:cNvPr id="84" name="TextBox 83">
+            <a:extLst>
+              <a:ext uri="{FF2B5EF4-FFF2-40B4-BE49-F238E27FC236}">
+                <a16:creationId xmlns:a16="http://schemas.microsoft.com/office/drawing/2014/main" id="{4A681769-29EB-965C-514F-E23DA676439F}"/>
+              </a:ext>
+            </a:extLst>
+          </p:cNvPr>
+          <p:cNvSpPr txBox="1"/>
+          <p:nvPr/>
+        </p:nvSpPr>
+        <p:spPr>
+          <a:xfrm>
+            <a:off x="1082841" y="32759357"/>
+            <a:ext cx="23031367" cy="2308324"/>
+          </a:xfrm>
+          <a:prstGeom prst="rect">
+            <a:avLst/>
+          </a:prstGeom>
+          <a:noFill/>
+        </p:spPr>
+        <p:txBody>
+          <a:bodyPr wrap="square" rtlCol="0">
+            <a:spAutoFit/>
+          </a:bodyPr>
+          <a:lstStyle/>
+          <a:p>
+            <a:r>
+              <a:rPr lang="hu-HU" sz="2400" b="1" dirty="0"/>
+              <a:t>Források</a:t>
+            </a:r>
+          </a:p>
+          <a:p>
+            <a:pPr marL="342900" indent="-342900">
+              <a:buFontTx/>
+              <a:buChar char="-"/>
+            </a:pPr>
+            <a:r>
+              <a:rPr lang="hu-HU" sz="2000" dirty="0"/>
+              <a:t>Projekt kód </a:t>
+            </a:r>
+            <a:r>
+              <a:rPr lang="hu-HU" sz="2000" dirty="0" err="1"/>
+              <a:t>repozitóriuma</a:t>
+            </a:r>
+            <a:r>
+              <a:rPr lang="hu-HU" sz="2000" dirty="0"/>
+              <a:t> - </a:t>
+            </a:r>
+            <a:r>
+              <a:rPr lang="en-US" sz="2000" dirty="0"/>
+              <a:t>GitHub: </a:t>
+            </a:r>
+            <a:r>
+              <a:rPr lang="en-US" sz="2000" dirty="0">
+                <a:hlinkClick r:id="rId8"/>
+              </a:rPr>
+              <a:t>https://github.com/ARTidas/DroneDefibrillator</a:t>
+            </a:r>
+            <a:r>
+              <a:rPr lang="hu-HU" sz="2000" dirty="0"/>
+              <a:t> </a:t>
+            </a:r>
+          </a:p>
+          <a:p>
+            <a:pPr marL="342900" indent="-342900">
+              <a:buFontTx/>
+              <a:buChar char="-"/>
+            </a:pPr>
+            <a:r>
+              <a:rPr lang="hu-HU" sz="2000" dirty="0"/>
+              <a:t>Helységlista - KSH:  </a:t>
+            </a:r>
+            <a:r>
+              <a:rPr lang="hu-HU" sz="2000" dirty="0">
+                <a:hlinkClick r:id="rId9"/>
+              </a:rPr>
+              <a:t>https://www.ksh.hu/apps/hntr.egyeb?p_lang=HU&amp;p_sablon=LETOLTES</a:t>
+            </a:r>
+            <a:endParaRPr lang="hu-HU" sz="2000" dirty="0"/>
+          </a:p>
+          <a:p>
+            <a:pPr marL="342900" indent="-342900">
+              <a:buFontTx/>
+              <a:buChar char="-"/>
+            </a:pPr>
+            <a:r>
+              <a:rPr lang="nl-NL" sz="2000" dirty="0"/>
+              <a:t>Drónok - DataVerse: </a:t>
+            </a:r>
+            <a:r>
+              <a:rPr lang="nl-NL" sz="2000" dirty="0">
+                <a:hlinkClick r:id="rId10"/>
+              </a:rPr>
+              <a:t>https://dataverse.no/dataset.xhtml?persistentId=doi:10.18710/L41IGQ</a:t>
+            </a:r>
+            <a:r>
+              <a:rPr lang="hu-HU" sz="2000" dirty="0"/>
+              <a:t> </a:t>
+            </a:r>
+          </a:p>
+          <a:p>
+            <a:pPr marL="342900" indent="-342900">
+              <a:buFontTx/>
+              <a:buChar char="-"/>
+            </a:pPr>
+            <a:r>
+              <a:rPr lang="hu-HU" sz="2000" dirty="0"/>
+              <a:t>Népsűrűség ellenőrzése: HDX - </a:t>
+            </a:r>
+            <a:r>
+              <a:rPr lang="hu-HU" sz="2000" dirty="0">
+                <a:hlinkClick r:id="rId11"/>
+              </a:rPr>
+              <a:t>https://data.humdata.org/dataset/worldpop-population-counts-2015-2030-hun</a:t>
+            </a:r>
+            <a:endParaRPr lang="hu-HU" sz="2000" dirty="0"/>
+          </a:p>
+          <a:p>
+            <a:pPr marL="342900" indent="-342900">
+              <a:buFontTx/>
+              <a:buChar char="-"/>
+            </a:pPr>
+            <a:r>
+              <a:rPr lang="pt-BR" sz="2000" dirty="0"/>
+              <a:t>Geográfiai koordináták - Nominatim API: </a:t>
+            </a:r>
+            <a:r>
+              <a:rPr lang="pt-BR" sz="2000" dirty="0">
+                <a:hlinkClick r:id="rId12"/>
+              </a:rPr>
+              <a:t>https://nominatim.org/</a:t>
+            </a:r>
+            <a:r>
+              <a:rPr lang="hu-HU" sz="2000" dirty="0"/>
+              <a:t> </a:t>
+            </a:r>
+          </a:p>
+          <a:p>
+            <a:pPr marL="342900" indent="-342900">
+              <a:buFontTx/>
+              <a:buChar char="-"/>
+            </a:pPr>
+            <a:r>
+              <a:rPr lang="hu-HU" sz="2000" dirty="0"/>
+              <a:t>Éves esetek száma – EgészségKalauz.hu : </a:t>
+            </a:r>
+            <a:r>
+              <a:rPr lang="hu-HU" sz="2000" dirty="0">
+                <a:hlinkClick r:id="rId13"/>
+              </a:rPr>
+              <a:t>https://www.egeszsegkalauz.hu/extra-ajanlo/a-magyar-emberek-fele-sziv-es-errendszeri-betegseg-miatt-veszti-eletet-hogyan/cz5jnx4</a:t>
+            </a:r>
+            <a:r>
+              <a:rPr lang="hu-HU" sz="2000" dirty="0"/>
+              <a:t> </a:t>
+            </a:r>
+            <a:endParaRPr lang="nl-NL" sz="2000" dirty="0"/>
+          </a:p>
+        </p:txBody>
+      </p:sp>
+    </p:spTree>
+    <p:extLst>
+      <p:ext uri="{BB962C8B-B14F-4D97-AF65-F5344CB8AC3E}">
+        <p14:creationId xmlns:p14="http://schemas.microsoft.com/office/powerpoint/2010/main" val="3920206288"/>
+      </p:ext>
+    </p:extLst>
+  </p:cSld>
+  <p:clrMapOvr>
+    <a:masterClrMapping/>
+  </p:clrMapOvr>
+</p:sld>
+</file>
+
+<file path=ppt/slides/slide3.xml><?xml version="1.0" encoding="utf-8"?>
+<p:sld xmlns:a="http://schemas.openxmlformats.org/drawingml/2006/main" xmlns:r="http://schemas.openxmlformats.org/officeDocument/2006/relationships" xmlns:p="http://schemas.openxmlformats.org/presentationml/2006/main">
+  <p:cSld>
+    <p:spTree>
+      <p:nvGrpSpPr>
+        <p:cNvPr id="1" name="">
+          <a:extLst>
+            <a:ext uri="{FF2B5EF4-FFF2-40B4-BE49-F238E27FC236}">
+              <a16:creationId xmlns:a16="http://schemas.microsoft.com/office/drawing/2014/main" id="{9A615AED-B58E-04B4-EAB2-A65A9D976A49}"/>
+            </a:ext>
+          </a:extLst>
+        </p:cNvPr>
+        <p:cNvGrpSpPr/>
+        <p:nvPr/>
+      </p:nvGrpSpPr>
+      <p:grpSpPr>
+        <a:xfrm>
+          <a:off x="0" y="0"/>
+          <a:ext cx="0" cy="0"/>
+          <a:chOff x="0" y="0"/>
+          <a:chExt cx="0" cy="0"/>
+        </a:xfrm>
+      </p:grpSpPr>
+      <p:sp>
+        <p:nvSpPr>
+          <p:cNvPr id="8" name="TextBox 7">
+            <a:extLst>
+              <a:ext uri="{FF2B5EF4-FFF2-40B4-BE49-F238E27FC236}">
+                <a16:creationId xmlns:a16="http://schemas.microsoft.com/office/drawing/2014/main" id="{167CDF49-C72D-12A5-CAF7-FD397AA0CACD}"/>
+              </a:ext>
+            </a:extLst>
+          </p:cNvPr>
+          <p:cNvSpPr txBox="1"/>
+          <p:nvPr/>
+        </p:nvSpPr>
+        <p:spPr>
+          <a:xfrm>
+            <a:off x="1082842" y="1469110"/>
+            <a:ext cx="23031365" cy="2092881"/>
+          </a:xfrm>
+          <a:prstGeom prst="rect">
+            <a:avLst/>
+          </a:prstGeom>
+          <a:noFill/>
+        </p:spPr>
+        <p:txBody>
+          <a:bodyPr wrap="square" rtlCol="0">
+            <a:spAutoFit/>
+          </a:bodyPr>
+          <a:lstStyle/>
+          <a:p>
+            <a:pPr algn="ctr"/>
+            <a:r>
+              <a:rPr lang="en-US" sz="6500" b="1" dirty="0"/>
+              <a:t>Automated external defibrillator (AED) delivery by drone:</a:t>
+            </a:r>
+            <a:br>
+              <a:rPr lang="en-US" sz="6500" b="1" dirty="0"/>
+            </a:br>
+            <a:r>
+              <a:rPr lang="en-US" sz="6500" dirty="0"/>
+              <a:t>Geospatial solutions and operations research optimization</a:t>
+            </a:r>
+          </a:p>
+        </p:txBody>
+      </p:sp>
+      <p:pic>
+        <p:nvPicPr>
+          <p:cNvPr id="17" name="Content Placeholder 13">
+            <a:extLst>
+              <a:ext uri="{FF2B5EF4-FFF2-40B4-BE49-F238E27FC236}">
+                <a16:creationId xmlns:a16="http://schemas.microsoft.com/office/drawing/2014/main" id="{B9B04A42-6201-376F-22F8-B89D95DC9DD4}"/>
+              </a:ext>
+            </a:extLst>
+          </p:cNvPr>
+          <p:cNvPicPr>
+            <a:picLocks noChangeAspect="1"/>
+          </p:cNvPicPr>
+          <p:nvPr/>
+        </p:nvPicPr>
+        <p:blipFill>
+          <a:blip r:embed="rId2">
+            <a:extLst>
+              <a:ext uri="{28A0092B-C50C-407E-A947-70E740481C1C}">
+                <a14:useLocalDpi xmlns:a14="http://schemas.microsoft.com/office/drawing/2010/main" val="0"/>
+              </a:ext>
+            </a:extLst>
+          </a:blip>
+          <a:stretch>
+            <a:fillRect/>
+          </a:stretch>
+        </p:blipFill>
+        <p:spPr>
+          <a:xfrm>
+            <a:off x="16623286" y="6846053"/>
+            <a:ext cx="4294181" cy="4294181"/>
+          </a:xfrm>
+          <a:prstGeom prst="rect">
+            <a:avLst/>
+          </a:prstGeom>
+        </p:spPr>
+      </p:pic>
+      <p:sp>
+        <p:nvSpPr>
+          <p:cNvPr id="25" name="TextBox 24">
+            <a:extLst>
+              <a:ext uri="{FF2B5EF4-FFF2-40B4-BE49-F238E27FC236}">
+                <a16:creationId xmlns:a16="http://schemas.microsoft.com/office/drawing/2014/main" id="{3BA24BF4-B53D-DF05-E817-0E193B361715}"/>
+              </a:ext>
+            </a:extLst>
+          </p:cNvPr>
+          <p:cNvSpPr txBox="1"/>
+          <p:nvPr/>
+        </p:nvSpPr>
+        <p:spPr>
+          <a:xfrm>
+            <a:off x="1082841" y="6505609"/>
+            <a:ext cx="11517146" cy="5816977"/>
+          </a:xfrm>
+          <a:prstGeom prst="rect">
+            <a:avLst/>
+          </a:prstGeom>
+          <a:noFill/>
+        </p:spPr>
+        <p:txBody>
+          <a:bodyPr wrap="square" rtlCol="0">
+            <a:spAutoFit/>
+          </a:bodyPr>
+          <a:lstStyle/>
+          <a:p>
+            <a:pPr algn="ctr"/>
+            <a:r>
+              <a:rPr lang="en-US" sz="6000" b="1" dirty="0"/>
+              <a:t>Abstract</a:t>
+            </a:r>
+          </a:p>
+          <a:p>
+            <a:pPr algn="just"/>
+            <a:r>
+              <a:rPr lang="en-US" sz="2400" dirty="0"/>
+              <a:t>To improve survival rates after cardiac arrest, delivering automated external defibrillators (AEDs) with drones could be an effective solution. Our study focuses on designing a Hungary-wide AED delivery drone network. For this purpose, we designed a database that contains the postal codes, the population count, and their geographical coordinates. The appropriate drone and thus the operational range (and payload) selection was made by weighting three parameters with multi-criteria decision analysis (MCDA): Top speed (0.5), operational range (0.2), weight (inverted 0.2), and payload (0.1). Demographic distribution was </a:t>
+            </a:r>
+            <a:r>
+              <a:rPr lang="en-US" sz="2400" dirty="0" err="1"/>
+              <a:t>visualised</a:t>
+            </a:r>
+            <a:r>
+              <a:rPr lang="en-US" sz="2400" dirty="0"/>
+              <a:t> with </a:t>
+            </a:r>
+            <a:r>
+              <a:rPr lang="en-US" sz="2400" dirty="0" err="1"/>
+              <a:t>isoband</a:t>
+            </a:r>
+            <a:r>
+              <a:rPr lang="en-US" sz="2400" dirty="0"/>
+              <a:t> lines and cross-checked visually with the help of a </a:t>
+            </a:r>
+            <a:r>
+              <a:rPr lang="en-US" sz="2400" dirty="0" err="1"/>
+              <a:t>GeoTiff</a:t>
+            </a:r>
+            <a:r>
+              <a:rPr lang="en-US" sz="2400" dirty="0"/>
+              <a:t> file. The placement of the drone bases was </a:t>
+            </a:r>
+            <a:r>
+              <a:rPr lang="en-US" sz="2400" dirty="0" err="1"/>
+              <a:t>optimised</a:t>
+            </a:r>
+            <a:r>
+              <a:rPr lang="en-US" sz="2400" dirty="0"/>
+              <a:t> by a capacity-constrained greedy algorithm based on the distribution of the yearly cases (63 000 / year). Our interactive web-based simulation demonstrates that with a 30 km operational radius, fewer than 50 bases are sufficient to cover at least 95% of the country’s demand.</a:t>
+            </a:r>
+          </a:p>
+        </p:txBody>
+      </p:sp>
+      <p:sp>
+        <p:nvSpPr>
+          <p:cNvPr id="41" name="TextBox 40">
+            <a:extLst>
+              <a:ext uri="{FF2B5EF4-FFF2-40B4-BE49-F238E27FC236}">
+                <a16:creationId xmlns:a16="http://schemas.microsoft.com/office/drawing/2014/main" id="{8E98CF32-603B-07C6-6ACE-1930CC307E48}"/>
+              </a:ext>
+            </a:extLst>
+          </p:cNvPr>
+          <p:cNvSpPr txBox="1"/>
+          <p:nvPr/>
+        </p:nvSpPr>
+        <p:spPr>
+          <a:xfrm>
+            <a:off x="16623287" y="4907061"/>
+            <a:ext cx="4294181" cy="1938992"/>
+          </a:xfrm>
+          <a:prstGeom prst="rect">
+            <a:avLst/>
+          </a:prstGeom>
+          <a:noFill/>
+        </p:spPr>
+        <p:txBody>
+          <a:bodyPr wrap="square" rtlCol="0">
+            <a:spAutoFit/>
+          </a:bodyPr>
+          <a:lstStyle/>
+          <a:p>
+            <a:pPr algn="ctr"/>
+            <a:r>
+              <a:rPr lang="hu-HU" sz="6000" b="1" dirty="0" err="1"/>
+              <a:t>Interactive</a:t>
+            </a:r>
+            <a:r>
+              <a:rPr lang="hu-HU" sz="6000" b="1" dirty="0"/>
+              <a:t> </a:t>
+            </a:r>
+            <a:r>
+              <a:rPr lang="hu-HU" sz="6000" b="1" dirty="0" err="1"/>
+              <a:t>simulation</a:t>
+            </a:r>
+            <a:r>
+              <a:rPr lang="hu-HU" sz="6000" b="1" dirty="0"/>
+              <a:t>!</a:t>
+            </a:r>
+          </a:p>
+        </p:txBody>
+      </p:sp>
+      <p:sp>
+        <p:nvSpPr>
+          <p:cNvPr id="45" name="TextBox 44">
+            <a:extLst>
+              <a:ext uri="{FF2B5EF4-FFF2-40B4-BE49-F238E27FC236}">
+                <a16:creationId xmlns:a16="http://schemas.microsoft.com/office/drawing/2014/main" id="{1F90357D-DF31-7944-C996-B68293DB70E7}"/>
+              </a:ext>
+            </a:extLst>
+          </p:cNvPr>
+          <p:cNvSpPr txBox="1"/>
+          <p:nvPr/>
+        </p:nvSpPr>
+        <p:spPr>
+          <a:xfrm>
+            <a:off x="1116939" y="3955328"/>
+            <a:ext cx="11359640" cy="1708160"/>
+          </a:xfrm>
+          <a:prstGeom prst="rect">
+            <a:avLst/>
+          </a:prstGeom>
+          <a:noFill/>
+        </p:spPr>
+        <p:txBody>
+          <a:bodyPr wrap="square" rtlCol="0">
+            <a:spAutoFit/>
+          </a:bodyPr>
+          <a:lstStyle/>
+          <a:p>
+            <a:r>
+              <a:rPr lang="hu-HU" sz="3500" dirty="0" err="1"/>
+              <a:t>Authors</a:t>
+            </a:r>
+            <a:r>
+              <a:rPr lang="hu-HU" sz="3500" dirty="0"/>
+              <a:t>:	Zoltán Veres, Dr. István Takács</a:t>
+            </a:r>
+          </a:p>
+          <a:p>
+            <a:r>
+              <a:rPr lang="hu-HU" sz="3500" dirty="0"/>
+              <a:t>				University of Tokaj, Lorántffy Institute</a:t>
+            </a:r>
+            <a:br>
+              <a:rPr lang="hu-HU" sz="3500" dirty="0"/>
+            </a:br>
+            <a:r>
+              <a:rPr lang="hu-HU" sz="3500" dirty="0"/>
+              <a:t>E-mail:		veres.zoltan@unithe.hu</a:t>
+            </a:r>
+          </a:p>
+        </p:txBody>
+      </p:sp>
+      <p:pic>
+        <p:nvPicPr>
+          <p:cNvPr id="49" name="Picture 48">
+            <a:extLst>
+              <a:ext uri="{FF2B5EF4-FFF2-40B4-BE49-F238E27FC236}">
+                <a16:creationId xmlns:a16="http://schemas.microsoft.com/office/drawing/2014/main" id="{5D8BD869-21D4-FA0B-2DA8-B6255A455468}"/>
+              </a:ext>
+            </a:extLst>
+          </p:cNvPr>
+          <p:cNvPicPr>
+            <a:picLocks noChangeAspect="1"/>
+          </p:cNvPicPr>
+          <p:nvPr/>
+        </p:nvPicPr>
+        <p:blipFill>
+          <a:blip r:embed="rId3"/>
+          <a:stretch>
+            <a:fillRect/>
+          </a:stretch>
+        </p:blipFill>
+        <p:spPr>
+          <a:xfrm>
+            <a:off x="12757491" y="12990628"/>
+            <a:ext cx="12260386" cy="7621064"/>
+          </a:xfrm>
+          <a:prstGeom prst="rect">
+            <a:avLst/>
+          </a:prstGeom>
+        </p:spPr>
+      </p:pic>
+      <p:sp>
+        <p:nvSpPr>
+          <p:cNvPr id="51" name="TextBox 50">
+            <a:extLst>
+              <a:ext uri="{FF2B5EF4-FFF2-40B4-BE49-F238E27FC236}">
+                <a16:creationId xmlns:a16="http://schemas.microsoft.com/office/drawing/2014/main" id="{061A4520-4EB0-F0E3-2F2E-D4A2B9EE63CC}"/>
+              </a:ext>
+            </a:extLst>
+          </p:cNvPr>
+          <p:cNvSpPr txBox="1"/>
+          <p:nvPr/>
+        </p:nvSpPr>
+        <p:spPr>
+          <a:xfrm>
+            <a:off x="1116939" y="12986206"/>
+            <a:ext cx="11359640" cy="7294305"/>
+          </a:xfrm>
+          <a:prstGeom prst="rect">
+            <a:avLst/>
+          </a:prstGeom>
+          <a:noFill/>
+        </p:spPr>
+        <p:txBody>
+          <a:bodyPr wrap="square" rtlCol="0">
+            <a:spAutoFit/>
+          </a:bodyPr>
+          <a:lstStyle/>
+          <a:p>
+            <a:pPr algn="ctr"/>
+            <a:r>
+              <a:rPr lang="hu-HU" sz="6000" b="1" dirty="0" err="1"/>
+              <a:t>Methodology</a:t>
+            </a:r>
+            <a:endParaRPr lang="hu-HU" sz="2400" dirty="0"/>
+          </a:p>
+          <a:p>
+            <a:pPr algn="just"/>
+            <a:r>
+              <a:rPr lang="hu-HU" sz="2400" dirty="0"/>
+              <a:t>The </a:t>
+            </a:r>
+            <a:r>
+              <a:rPr lang="hu-HU" sz="2400" dirty="0" err="1"/>
+              <a:t>research</a:t>
+            </a:r>
+            <a:r>
+              <a:rPr lang="hu-HU" sz="2400" dirty="0"/>
+              <a:t> is </a:t>
+            </a:r>
+            <a:r>
+              <a:rPr lang="hu-HU" sz="2400" dirty="0" err="1"/>
+              <a:t>based</a:t>
+            </a:r>
+            <a:r>
+              <a:rPr lang="hu-HU" sz="2400" dirty="0"/>
+              <a:t> </a:t>
+            </a:r>
+            <a:r>
+              <a:rPr lang="hu-HU" sz="2400" dirty="0" err="1"/>
+              <a:t>on</a:t>
+            </a:r>
+            <a:r>
+              <a:rPr lang="hu-HU" sz="2400" dirty="0"/>
+              <a:t> a </a:t>
+            </a:r>
+            <a:r>
+              <a:rPr lang="hu-HU" sz="2400" dirty="0" err="1"/>
+              <a:t>data-driven</a:t>
+            </a:r>
+            <a:r>
+              <a:rPr lang="hu-HU" sz="2400" dirty="0"/>
+              <a:t> </a:t>
+            </a:r>
+            <a:r>
+              <a:rPr lang="hu-HU" sz="2400" dirty="0" err="1"/>
+              <a:t>framework</a:t>
+            </a:r>
+            <a:r>
+              <a:rPr lang="hu-HU" sz="2400" dirty="0"/>
+              <a:t>, </a:t>
+            </a:r>
+            <a:r>
+              <a:rPr lang="hu-HU" sz="2400" dirty="0" err="1"/>
+              <a:t>which</a:t>
+            </a:r>
+            <a:r>
+              <a:rPr lang="hu-HU" sz="2400" dirty="0"/>
+              <a:t> </a:t>
+            </a:r>
+            <a:r>
+              <a:rPr lang="hu-HU" sz="2400" dirty="0" err="1"/>
+              <a:t>combines</a:t>
+            </a:r>
+            <a:r>
+              <a:rPr lang="hu-HU" sz="2400" dirty="0"/>
+              <a:t> </a:t>
+            </a:r>
+            <a:r>
+              <a:rPr lang="hu-HU" sz="2400" dirty="0" err="1"/>
+              <a:t>geographical</a:t>
+            </a:r>
+            <a:r>
+              <a:rPr lang="hu-HU" sz="2400" dirty="0"/>
+              <a:t> </a:t>
+            </a:r>
+            <a:r>
+              <a:rPr lang="hu-HU" sz="2400" dirty="0" err="1"/>
+              <a:t>information</a:t>
+            </a:r>
+            <a:r>
+              <a:rPr lang="hu-HU" sz="2400" dirty="0"/>
+              <a:t> </a:t>
+            </a:r>
+            <a:r>
+              <a:rPr lang="hu-HU" sz="2400" dirty="0" err="1"/>
+              <a:t>systems</a:t>
+            </a:r>
+            <a:r>
+              <a:rPr lang="hu-HU" sz="2400" dirty="0"/>
+              <a:t> (GIS) in </a:t>
+            </a:r>
+            <a:r>
+              <a:rPr lang="hu-HU" sz="2400" dirty="0" err="1"/>
+              <a:t>four</a:t>
+            </a:r>
+            <a:r>
+              <a:rPr lang="hu-HU" sz="2400" dirty="0"/>
+              <a:t> </a:t>
+            </a:r>
+            <a:r>
+              <a:rPr lang="hu-HU" sz="2400" dirty="0" err="1"/>
+              <a:t>steps</a:t>
+            </a:r>
+            <a:r>
+              <a:rPr lang="hu-HU" sz="2400" dirty="0"/>
+              <a:t>:</a:t>
+            </a:r>
+            <a:br>
+              <a:rPr lang="hu-HU" sz="2400" dirty="0"/>
+            </a:br>
+            <a:r>
+              <a:rPr lang="hu-HU" sz="2400" b="1" dirty="0"/>
+              <a:t>GIS </a:t>
+            </a:r>
+            <a:r>
+              <a:rPr lang="hu-HU" sz="2400" b="1" dirty="0" err="1"/>
+              <a:t>modeling</a:t>
+            </a:r>
+            <a:r>
+              <a:rPr lang="hu-HU" sz="2400" b="1" dirty="0"/>
+              <a:t>:</a:t>
+            </a:r>
+            <a:r>
+              <a:rPr lang="hu-HU" sz="2400" dirty="0"/>
+              <a:t> </a:t>
+            </a:r>
+            <a:r>
+              <a:rPr lang="hu-HU" sz="2400" dirty="0" err="1"/>
+              <a:t>We</a:t>
+            </a:r>
+            <a:r>
+              <a:rPr lang="hu-HU" sz="2400" dirty="0"/>
+              <a:t> </a:t>
+            </a:r>
+            <a:r>
+              <a:rPr lang="hu-HU" sz="2400" dirty="0" err="1"/>
+              <a:t>determined</a:t>
+            </a:r>
+            <a:r>
+              <a:rPr lang="hu-HU" sz="2400" dirty="0"/>
+              <a:t> </a:t>
+            </a:r>
+            <a:r>
+              <a:rPr lang="hu-HU" sz="2400" dirty="0" err="1"/>
+              <a:t>the</a:t>
+            </a:r>
+            <a:r>
+              <a:rPr lang="hu-HU" sz="2400" dirty="0"/>
+              <a:t> </a:t>
+            </a:r>
+            <a:r>
+              <a:rPr lang="hu-HU" sz="2400" dirty="0" err="1"/>
+              <a:t>distribution</a:t>
+            </a:r>
+            <a:r>
+              <a:rPr lang="hu-HU" sz="2400" dirty="0"/>
+              <a:t> of </a:t>
+            </a:r>
+            <a:r>
+              <a:rPr lang="hu-HU" sz="2400" dirty="0" err="1"/>
+              <a:t>Hungary's</a:t>
+            </a:r>
+            <a:r>
+              <a:rPr lang="hu-HU" sz="2400" dirty="0"/>
+              <a:t> </a:t>
+            </a:r>
+            <a:r>
+              <a:rPr lang="hu-HU" sz="2400" dirty="0" err="1"/>
+              <a:t>population</a:t>
+            </a:r>
+            <a:r>
+              <a:rPr lang="hu-HU" sz="2400" dirty="0"/>
+              <a:t> </a:t>
+            </a:r>
+            <a:r>
+              <a:rPr lang="hu-HU" sz="2400" dirty="0" err="1"/>
+              <a:t>based</a:t>
+            </a:r>
+            <a:r>
+              <a:rPr lang="hu-HU" sz="2400" dirty="0"/>
+              <a:t> </a:t>
+            </a:r>
+            <a:r>
+              <a:rPr lang="hu-HU" sz="2400" dirty="0" err="1"/>
+              <a:t>on</a:t>
+            </a:r>
+            <a:r>
+              <a:rPr lang="hu-HU" sz="2400" dirty="0"/>
+              <a:t> </a:t>
+            </a:r>
+            <a:r>
+              <a:rPr lang="hu-HU" sz="2400" dirty="0" err="1"/>
+              <a:t>postal-code</a:t>
+            </a:r>
+            <a:r>
+              <a:rPr lang="hu-HU" sz="2400" dirty="0"/>
+              <a:t> </a:t>
+            </a:r>
+            <a:r>
+              <a:rPr lang="hu-HU" sz="2400" dirty="0" err="1"/>
+              <a:t>level</a:t>
+            </a:r>
+            <a:r>
+              <a:rPr lang="hu-HU" sz="2400" dirty="0"/>
+              <a:t> </a:t>
+            </a:r>
+            <a:r>
+              <a:rPr lang="hu-HU" sz="2400" dirty="0" err="1"/>
+              <a:t>demographic</a:t>
+            </a:r>
+            <a:r>
+              <a:rPr lang="hu-HU" sz="2400" dirty="0"/>
+              <a:t> </a:t>
+            </a:r>
+            <a:r>
+              <a:rPr lang="hu-HU" sz="2400" dirty="0" err="1"/>
+              <a:t>data</a:t>
+            </a:r>
+            <a:r>
+              <a:rPr lang="hu-HU" sz="2400" dirty="0"/>
+              <a:t>, </a:t>
+            </a:r>
+            <a:r>
+              <a:rPr lang="hu-HU" sz="2400" dirty="0" err="1"/>
+              <a:t>which</a:t>
+            </a:r>
+            <a:r>
+              <a:rPr lang="hu-HU" sz="2400" dirty="0"/>
+              <a:t> </a:t>
+            </a:r>
+            <a:r>
+              <a:rPr lang="hu-HU" sz="2400" dirty="0" err="1"/>
+              <a:t>were</a:t>
+            </a:r>
+            <a:r>
+              <a:rPr lang="hu-HU" sz="2400" dirty="0"/>
+              <a:t> </a:t>
+            </a:r>
+            <a:r>
+              <a:rPr lang="hu-HU" sz="2400" dirty="0" err="1"/>
+              <a:t>visualised</a:t>
+            </a:r>
+            <a:r>
+              <a:rPr lang="hu-HU" sz="2400" dirty="0"/>
+              <a:t> </a:t>
+            </a:r>
+            <a:r>
+              <a:rPr lang="hu-HU" sz="2400" dirty="0" err="1"/>
+              <a:t>with</a:t>
+            </a:r>
+            <a:r>
+              <a:rPr lang="hu-HU" sz="2400" dirty="0"/>
+              <a:t> </a:t>
+            </a:r>
+            <a:r>
+              <a:rPr lang="hu-HU" sz="2400" dirty="0" err="1"/>
+              <a:t>isobands</a:t>
+            </a:r>
+            <a:r>
+              <a:rPr lang="hu-HU" sz="2400" dirty="0"/>
+              <a:t>. The </a:t>
+            </a:r>
+            <a:r>
+              <a:rPr lang="hu-HU" sz="2400" dirty="0" err="1"/>
+              <a:t>model</a:t>
+            </a:r>
+            <a:r>
+              <a:rPr lang="hu-HU" sz="2400" dirty="0"/>
+              <a:t> </a:t>
+            </a:r>
+            <a:r>
+              <a:rPr lang="hu-HU" sz="2400" dirty="0" err="1"/>
+              <a:t>was</a:t>
+            </a:r>
+            <a:r>
+              <a:rPr lang="hu-HU" sz="2400" dirty="0"/>
+              <a:t> </a:t>
+            </a:r>
+            <a:r>
+              <a:rPr lang="hu-HU" sz="2400" dirty="0" err="1"/>
+              <a:t>visually</a:t>
+            </a:r>
+            <a:r>
+              <a:rPr lang="hu-HU" sz="2400" dirty="0"/>
+              <a:t> </a:t>
+            </a:r>
+            <a:r>
+              <a:rPr lang="hu-HU" sz="2400" dirty="0" err="1"/>
+              <a:t>cross-referenced</a:t>
+            </a:r>
+            <a:r>
+              <a:rPr lang="hu-HU" sz="2400" dirty="0"/>
+              <a:t> </a:t>
+            </a:r>
+            <a:r>
+              <a:rPr lang="hu-HU" sz="2400" dirty="0" err="1"/>
+              <a:t>with</a:t>
+            </a:r>
+            <a:r>
+              <a:rPr lang="hu-HU" sz="2400" dirty="0"/>
+              <a:t> a 100 </a:t>
+            </a:r>
+            <a:r>
+              <a:rPr lang="hu-HU" sz="2400" dirty="0" err="1"/>
+              <a:t>meter</a:t>
+            </a:r>
+            <a:r>
+              <a:rPr lang="hu-HU" sz="2400" dirty="0"/>
+              <a:t> </a:t>
+            </a:r>
+            <a:r>
+              <a:rPr lang="hu-HU" sz="2400" dirty="0" err="1"/>
+              <a:t>resolution</a:t>
+            </a:r>
+            <a:r>
+              <a:rPr lang="hu-HU" sz="2400" dirty="0"/>
+              <a:t> </a:t>
+            </a:r>
+            <a:r>
+              <a:rPr lang="hu-HU" sz="2400" dirty="0" err="1"/>
+              <a:t>raster</a:t>
+            </a:r>
+            <a:r>
+              <a:rPr lang="hu-HU" sz="2400" dirty="0"/>
+              <a:t> (</a:t>
+            </a:r>
+            <a:r>
+              <a:rPr lang="hu-HU" sz="2400" dirty="0" err="1"/>
+              <a:t>GeoTiff</a:t>
+            </a:r>
+            <a:r>
+              <a:rPr lang="hu-HU" sz="2400" dirty="0"/>
+              <a:t>) </a:t>
+            </a:r>
+            <a:r>
+              <a:rPr lang="hu-HU" sz="2400" dirty="0" err="1"/>
+              <a:t>population</a:t>
+            </a:r>
+            <a:r>
+              <a:rPr lang="hu-HU" sz="2400" dirty="0"/>
+              <a:t> </a:t>
+            </a:r>
+            <a:r>
+              <a:rPr lang="hu-HU" sz="2400" dirty="0" err="1"/>
+              <a:t>density</a:t>
+            </a:r>
+            <a:r>
+              <a:rPr lang="hu-HU" sz="2400" dirty="0"/>
+              <a:t> </a:t>
+            </a:r>
+            <a:r>
+              <a:rPr lang="hu-HU" sz="2400" dirty="0" err="1"/>
+              <a:t>dataset</a:t>
+            </a:r>
+            <a:r>
+              <a:rPr lang="hu-HU" sz="2400" dirty="0"/>
+              <a:t>.</a:t>
+            </a:r>
+            <a:br>
+              <a:rPr lang="hu-HU" sz="2400" dirty="0"/>
+            </a:br>
+            <a:r>
+              <a:rPr lang="hu-HU" sz="2400" b="1" dirty="0"/>
+              <a:t>Multi-</a:t>
+            </a:r>
+            <a:r>
+              <a:rPr lang="hu-HU" sz="2400" b="1" dirty="0" err="1"/>
+              <a:t>criteria</a:t>
+            </a:r>
+            <a:r>
+              <a:rPr lang="hu-HU" sz="2400" b="1" dirty="0"/>
+              <a:t> decision </a:t>
+            </a:r>
+            <a:r>
+              <a:rPr lang="hu-HU" sz="2400" b="1" dirty="0" err="1"/>
+              <a:t>analysis</a:t>
+            </a:r>
+            <a:r>
+              <a:rPr lang="hu-HU" sz="2400" b="1" dirty="0"/>
+              <a:t> (MCDA):</a:t>
+            </a:r>
+            <a:r>
+              <a:rPr lang="hu-HU" sz="2400" dirty="0"/>
+              <a:t> </a:t>
+            </a:r>
+            <a:r>
+              <a:rPr lang="hu-HU" sz="2400" dirty="0" err="1"/>
+              <a:t>We</a:t>
+            </a:r>
+            <a:r>
+              <a:rPr lang="hu-HU" sz="2400" dirty="0"/>
+              <a:t> </a:t>
+            </a:r>
+            <a:r>
+              <a:rPr lang="hu-HU" sz="2400" dirty="0" err="1"/>
+              <a:t>selected</a:t>
+            </a:r>
+            <a:r>
+              <a:rPr lang="hu-HU" sz="2400" dirty="0"/>
+              <a:t> </a:t>
+            </a:r>
+            <a:r>
+              <a:rPr lang="hu-HU" sz="2400" dirty="0" err="1"/>
+              <a:t>the</a:t>
+            </a:r>
+            <a:r>
+              <a:rPr lang="hu-HU" sz="2400" dirty="0"/>
+              <a:t> most </a:t>
+            </a:r>
+            <a:r>
+              <a:rPr lang="hu-HU" sz="2400" dirty="0" err="1"/>
+              <a:t>suitable</a:t>
+            </a:r>
+            <a:r>
+              <a:rPr lang="hu-HU" sz="2400" dirty="0"/>
+              <a:t> </a:t>
+            </a:r>
+            <a:r>
+              <a:rPr lang="hu-HU" sz="2400" dirty="0" err="1"/>
+              <a:t>drone</a:t>
+            </a:r>
+            <a:r>
+              <a:rPr lang="hu-HU" sz="2400" dirty="0"/>
+              <a:t> </a:t>
+            </a:r>
+            <a:r>
+              <a:rPr lang="hu-HU" sz="2400" dirty="0" err="1"/>
+              <a:t>for</a:t>
+            </a:r>
+            <a:r>
+              <a:rPr lang="hu-HU" sz="2400" dirty="0"/>
+              <a:t> </a:t>
+            </a:r>
+            <a:r>
+              <a:rPr lang="hu-HU" sz="2400" dirty="0" err="1"/>
+              <a:t>the</a:t>
+            </a:r>
+            <a:r>
+              <a:rPr lang="hu-HU" sz="2400" dirty="0"/>
+              <a:t> </a:t>
+            </a:r>
+            <a:r>
+              <a:rPr lang="hu-HU" sz="2400" dirty="0" err="1"/>
+              <a:t>task</a:t>
+            </a:r>
+            <a:r>
+              <a:rPr lang="hu-HU" sz="2400" dirty="0"/>
+              <a:t> </a:t>
+            </a:r>
+            <a:r>
+              <a:rPr lang="hu-HU" sz="2400" dirty="0" err="1"/>
+              <a:t>using</a:t>
+            </a:r>
+            <a:r>
+              <a:rPr lang="hu-HU" sz="2400" dirty="0"/>
+              <a:t> a </a:t>
+            </a:r>
+            <a:r>
+              <a:rPr lang="hu-HU" sz="2400" dirty="0" err="1"/>
+              <a:t>weighted</a:t>
+            </a:r>
+            <a:r>
+              <a:rPr lang="hu-HU" sz="2400" dirty="0"/>
+              <a:t> </a:t>
+            </a:r>
+            <a:r>
+              <a:rPr lang="hu-HU" sz="2400" dirty="0" err="1"/>
+              <a:t>scoring</a:t>
+            </a:r>
+            <a:r>
+              <a:rPr lang="hu-HU" sz="2400" dirty="0"/>
+              <a:t> </a:t>
+            </a:r>
+            <a:r>
+              <a:rPr lang="hu-HU" sz="2400" dirty="0" err="1"/>
+              <a:t>system</a:t>
+            </a:r>
+            <a:r>
+              <a:rPr lang="hu-HU" sz="2400" dirty="0"/>
+              <a:t>. The </a:t>
+            </a:r>
+            <a:r>
+              <a:rPr lang="hu-HU" sz="2400" dirty="0" err="1"/>
+              <a:t>model</a:t>
+            </a:r>
+            <a:r>
+              <a:rPr lang="hu-HU" sz="2400" dirty="0"/>
+              <a:t> </a:t>
+            </a:r>
+            <a:r>
+              <a:rPr lang="hu-HU" sz="2400" dirty="0" err="1"/>
+              <a:t>considered</a:t>
+            </a:r>
+            <a:r>
+              <a:rPr lang="hu-HU" sz="2400" dirty="0"/>
+              <a:t> top </a:t>
+            </a:r>
+            <a:r>
+              <a:rPr lang="hu-HU" sz="2400" dirty="0" err="1"/>
+              <a:t>speed</a:t>
+            </a:r>
+            <a:r>
+              <a:rPr lang="hu-HU" sz="2400" dirty="0"/>
+              <a:t> (50%), </a:t>
+            </a:r>
+            <a:r>
+              <a:rPr lang="hu-HU" sz="2400" dirty="0" err="1"/>
+              <a:t>operational</a:t>
+            </a:r>
+            <a:r>
+              <a:rPr lang="hu-HU" sz="2400" dirty="0"/>
+              <a:t> </a:t>
+            </a:r>
+            <a:r>
+              <a:rPr lang="hu-HU" sz="2400" dirty="0" err="1"/>
+              <a:t>range</a:t>
+            </a:r>
+            <a:r>
+              <a:rPr lang="hu-HU" sz="2400" dirty="0"/>
+              <a:t> (20%), maximum </a:t>
+            </a:r>
+            <a:r>
+              <a:rPr lang="hu-HU" sz="2400" dirty="0" err="1"/>
+              <a:t>take-off</a:t>
+            </a:r>
+            <a:r>
+              <a:rPr lang="hu-HU" sz="2400" dirty="0"/>
+              <a:t> </a:t>
+            </a:r>
+            <a:r>
+              <a:rPr lang="hu-HU" sz="2400" dirty="0" err="1"/>
+              <a:t>weight</a:t>
+            </a:r>
+            <a:r>
+              <a:rPr lang="hu-HU" sz="2400" dirty="0"/>
+              <a:t> – </a:t>
+            </a:r>
+            <a:r>
+              <a:rPr lang="hu-HU" sz="2400" dirty="0" err="1"/>
+              <a:t>safety</a:t>
+            </a:r>
+            <a:r>
+              <a:rPr lang="hu-HU" sz="2400" dirty="0"/>
+              <a:t> and </a:t>
+            </a:r>
+            <a:r>
+              <a:rPr lang="hu-HU" sz="2400" dirty="0" err="1"/>
+              <a:t>handling</a:t>
+            </a:r>
+            <a:r>
+              <a:rPr lang="hu-HU" sz="2400" dirty="0"/>
+              <a:t> – (</a:t>
+            </a:r>
+            <a:r>
+              <a:rPr lang="hu-HU" sz="2400" dirty="0" err="1"/>
+              <a:t>inverted</a:t>
+            </a:r>
+            <a:r>
+              <a:rPr lang="hu-HU" sz="2400" dirty="0"/>
+              <a:t> 20%), and </a:t>
+            </a:r>
+            <a:r>
+              <a:rPr lang="hu-HU" sz="2400" dirty="0" err="1"/>
+              <a:t>payload</a:t>
+            </a:r>
+            <a:r>
+              <a:rPr lang="hu-HU" sz="2400" dirty="0"/>
+              <a:t> </a:t>
+            </a:r>
+            <a:r>
+              <a:rPr lang="hu-HU" sz="2400" dirty="0" err="1"/>
+              <a:t>capacity</a:t>
+            </a:r>
+            <a:r>
+              <a:rPr lang="hu-HU" sz="2400" dirty="0"/>
+              <a:t> (10%).</a:t>
+            </a:r>
+            <a:br>
+              <a:rPr lang="hu-HU" sz="2400" dirty="0"/>
+            </a:br>
+            <a:r>
+              <a:rPr lang="hu-HU" sz="2400" b="1" dirty="0"/>
+              <a:t>Network </a:t>
+            </a:r>
+            <a:r>
+              <a:rPr lang="hu-HU" sz="2400" b="1" dirty="0" err="1"/>
+              <a:t>optimisation</a:t>
+            </a:r>
+            <a:r>
+              <a:rPr lang="hu-HU" sz="2400" b="1" dirty="0"/>
+              <a:t>:</a:t>
+            </a:r>
+            <a:r>
+              <a:rPr lang="hu-HU" sz="2400" dirty="0"/>
+              <a:t> </a:t>
+            </a:r>
+            <a:r>
+              <a:rPr lang="hu-HU" sz="2400" dirty="0" err="1"/>
+              <a:t>We</a:t>
+            </a:r>
+            <a:r>
+              <a:rPr lang="hu-HU" sz="2400" dirty="0"/>
+              <a:t> </a:t>
+            </a:r>
+            <a:r>
+              <a:rPr lang="hu-HU" sz="2400" dirty="0" err="1"/>
+              <a:t>approached</a:t>
+            </a:r>
+            <a:r>
+              <a:rPr lang="hu-HU" sz="2400" dirty="0"/>
+              <a:t> </a:t>
+            </a:r>
+            <a:r>
+              <a:rPr lang="hu-HU" sz="2400" dirty="0" err="1"/>
+              <a:t>the</a:t>
+            </a:r>
+            <a:r>
+              <a:rPr lang="hu-HU" sz="2400" dirty="0"/>
+              <a:t> </a:t>
+            </a:r>
+            <a:r>
+              <a:rPr lang="hu-HU" sz="2400" dirty="0" err="1"/>
+              <a:t>placement</a:t>
+            </a:r>
+            <a:r>
+              <a:rPr lang="hu-HU" sz="2400" dirty="0"/>
+              <a:t> of </a:t>
+            </a:r>
+            <a:r>
+              <a:rPr lang="hu-HU" sz="2400" dirty="0" err="1"/>
+              <a:t>the</a:t>
+            </a:r>
+            <a:r>
+              <a:rPr lang="hu-HU" sz="2400" dirty="0"/>
+              <a:t> </a:t>
+            </a:r>
+            <a:r>
+              <a:rPr lang="hu-HU" sz="2400" dirty="0" err="1"/>
+              <a:t>drone</a:t>
+            </a:r>
+            <a:r>
+              <a:rPr lang="hu-HU" sz="2400" dirty="0"/>
+              <a:t> </a:t>
+            </a:r>
+            <a:r>
+              <a:rPr lang="hu-HU" sz="2400" dirty="0" err="1"/>
+              <a:t>bases</a:t>
+            </a:r>
+            <a:r>
+              <a:rPr lang="hu-HU" sz="2400" dirty="0"/>
+              <a:t> </a:t>
+            </a:r>
+            <a:r>
+              <a:rPr lang="hu-HU" sz="2400" dirty="0" err="1"/>
+              <a:t>as</a:t>
+            </a:r>
+            <a:r>
+              <a:rPr lang="hu-HU" sz="2400" dirty="0"/>
+              <a:t> a </a:t>
+            </a:r>
+            <a:r>
+              <a:rPr lang="hu-HU" sz="2400" dirty="0" err="1"/>
+              <a:t>facility</a:t>
+            </a:r>
+            <a:r>
+              <a:rPr lang="hu-HU" sz="2400" dirty="0"/>
+              <a:t> </a:t>
+            </a:r>
+            <a:r>
+              <a:rPr lang="hu-HU" sz="2400" dirty="0" err="1"/>
+              <a:t>location</a:t>
+            </a:r>
+            <a:r>
+              <a:rPr lang="hu-HU" sz="2400" dirty="0"/>
+              <a:t> </a:t>
+            </a:r>
+            <a:r>
+              <a:rPr lang="hu-HU" sz="2400" dirty="0" err="1"/>
+              <a:t>problem</a:t>
+            </a:r>
+            <a:r>
+              <a:rPr lang="hu-HU" sz="2400" dirty="0"/>
+              <a:t>. </a:t>
+            </a:r>
+            <a:r>
+              <a:rPr lang="hu-HU" sz="2400" dirty="0" err="1"/>
+              <a:t>By</a:t>
+            </a:r>
+            <a:r>
+              <a:rPr lang="hu-HU" sz="2400" dirty="0"/>
+              <a:t> </a:t>
+            </a:r>
+            <a:r>
+              <a:rPr lang="hu-HU" sz="2400" dirty="0" err="1"/>
+              <a:t>utilising</a:t>
+            </a:r>
+            <a:r>
+              <a:rPr lang="hu-HU" sz="2400" dirty="0"/>
+              <a:t> a </a:t>
+            </a:r>
+            <a:r>
+              <a:rPr lang="hu-HU" sz="2400" dirty="0" err="1"/>
+              <a:t>capacity-restrained</a:t>
+            </a:r>
+            <a:r>
+              <a:rPr lang="hu-HU" sz="2400" dirty="0"/>
+              <a:t> </a:t>
+            </a:r>
+            <a:r>
+              <a:rPr lang="hu-HU" sz="2400" dirty="0" err="1"/>
+              <a:t>greedy</a:t>
+            </a:r>
+            <a:r>
+              <a:rPr lang="hu-HU" sz="2400" dirty="0"/>
+              <a:t> </a:t>
+            </a:r>
+            <a:r>
+              <a:rPr lang="hu-HU" sz="2400" dirty="0" err="1"/>
+              <a:t>algorithm</a:t>
+            </a:r>
+            <a:r>
+              <a:rPr lang="hu-HU" sz="2400" dirty="0"/>
+              <a:t> </a:t>
+            </a:r>
+            <a:r>
+              <a:rPr lang="hu-HU" sz="2400" dirty="0" err="1"/>
+              <a:t>to</a:t>
+            </a:r>
+            <a:r>
+              <a:rPr lang="hu-HU" sz="2400" dirty="0"/>
+              <a:t> minimise </a:t>
+            </a:r>
+            <a:r>
+              <a:rPr lang="hu-HU" sz="2400" dirty="0" err="1"/>
+              <a:t>the</a:t>
+            </a:r>
+            <a:r>
+              <a:rPr lang="hu-HU" sz="2400" dirty="0"/>
+              <a:t> </a:t>
+            </a:r>
+            <a:r>
+              <a:rPr lang="hu-HU" sz="2400" dirty="0" err="1"/>
+              <a:t>number</a:t>
+            </a:r>
+            <a:r>
+              <a:rPr lang="hu-HU" sz="2400" dirty="0"/>
+              <a:t> of </a:t>
+            </a:r>
+            <a:r>
+              <a:rPr lang="hu-HU" sz="2400" dirty="0" err="1"/>
+              <a:t>required</a:t>
+            </a:r>
+            <a:r>
+              <a:rPr lang="hu-HU" sz="2400" dirty="0"/>
+              <a:t> </a:t>
+            </a:r>
+            <a:r>
+              <a:rPr lang="hu-HU" sz="2400" dirty="0" err="1"/>
+              <a:t>drone</a:t>
+            </a:r>
+            <a:r>
+              <a:rPr lang="hu-HU" sz="2400" dirty="0"/>
+              <a:t> </a:t>
+            </a:r>
+            <a:r>
+              <a:rPr lang="hu-HU" sz="2400" dirty="0" err="1"/>
+              <a:t>bases</a:t>
+            </a:r>
+            <a:r>
+              <a:rPr lang="hu-HU" sz="2400" dirty="0"/>
+              <a:t>, </a:t>
+            </a:r>
+            <a:r>
+              <a:rPr lang="hu-HU" sz="2400" dirty="0" err="1"/>
+              <a:t>based</a:t>
+            </a:r>
+            <a:r>
+              <a:rPr lang="hu-HU" sz="2400" dirty="0"/>
+              <a:t> </a:t>
+            </a:r>
+            <a:r>
+              <a:rPr lang="hu-HU" sz="2400" dirty="0" err="1"/>
+              <a:t>on</a:t>
+            </a:r>
+            <a:r>
+              <a:rPr lang="hu-HU" sz="2400" dirty="0"/>
+              <a:t> </a:t>
+            </a:r>
+            <a:r>
+              <a:rPr lang="hu-HU" sz="2400" dirty="0" err="1"/>
+              <a:t>the</a:t>
+            </a:r>
+            <a:r>
+              <a:rPr lang="hu-HU" sz="2400" dirty="0"/>
+              <a:t> </a:t>
+            </a:r>
+            <a:r>
+              <a:rPr lang="hu-HU" sz="2400" dirty="0" err="1"/>
+              <a:t>population-weighted</a:t>
+            </a:r>
+            <a:r>
+              <a:rPr lang="hu-HU" sz="2400" dirty="0"/>
+              <a:t> </a:t>
+            </a:r>
+            <a:r>
+              <a:rPr lang="hu-HU" sz="2400" dirty="0" err="1"/>
+              <a:t>distribution</a:t>
+            </a:r>
+            <a:r>
+              <a:rPr lang="hu-HU" sz="2400" dirty="0"/>
+              <a:t> of an </a:t>
+            </a:r>
+            <a:r>
+              <a:rPr lang="hu-HU" sz="2400" dirty="0" err="1"/>
+              <a:t>estimated</a:t>
+            </a:r>
+            <a:r>
+              <a:rPr lang="hu-HU" sz="2400" dirty="0"/>
+              <a:t> 63 000 </a:t>
+            </a:r>
+            <a:r>
+              <a:rPr lang="hu-HU" sz="2400" dirty="0" err="1"/>
+              <a:t>annual</a:t>
+            </a:r>
+            <a:r>
+              <a:rPr lang="hu-HU" sz="2400" dirty="0"/>
+              <a:t> </a:t>
+            </a:r>
+            <a:r>
+              <a:rPr lang="hu-HU" sz="2400" dirty="0" err="1"/>
+              <a:t>domestic</a:t>
+            </a:r>
+            <a:r>
+              <a:rPr lang="hu-HU" sz="2400" dirty="0"/>
+              <a:t> </a:t>
+            </a:r>
+            <a:r>
+              <a:rPr lang="hu-HU" sz="2400" dirty="0" err="1"/>
+              <a:t>cases</a:t>
+            </a:r>
+            <a:r>
+              <a:rPr lang="hu-HU" sz="2400" dirty="0"/>
+              <a:t>.</a:t>
+            </a:r>
+            <a:br>
+              <a:rPr lang="hu-HU" sz="2400" dirty="0"/>
+            </a:br>
+            <a:r>
+              <a:rPr lang="hu-HU" sz="2400" b="1" dirty="0" err="1"/>
+              <a:t>Interactive</a:t>
+            </a:r>
+            <a:r>
+              <a:rPr lang="hu-HU" sz="2400" b="1" dirty="0"/>
+              <a:t> </a:t>
+            </a:r>
+            <a:r>
+              <a:rPr lang="hu-HU" sz="2400" b="1" dirty="0" err="1"/>
+              <a:t>simulation</a:t>
+            </a:r>
+            <a:r>
+              <a:rPr lang="hu-HU" sz="2400" b="1" dirty="0"/>
+              <a:t>:</a:t>
+            </a:r>
+            <a:r>
+              <a:rPr lang="hu-HU" sz="2400" dirty="0"/>
+              <a:t> </a:t>
+            </a:r>
+            <a:r>
+              <a:rPr lang="hu-HU" sz="2400" dirty="0" err="1"/>
+              <a:t>We</a:t>
+            </a:r>
+            <a:r>
+              <a:rPr lang="hu-HU" sz="2400" dirty="0"/>
+              <a:t> </a:t>
+            </a:r>
+            <a:r>
+              <a:rPr lang="hu-HU" sz="2400" dirty="0" err="1"/>
+              <a:t>developed</a:t>
+            </a:r>
+            <a:r>
+              <a:rPr lang="hu-HU" sz="2400" dirty="0"/>
+              <a:t> a web-</a:t>
+            </a:r>
+            <a:r>
+              <a:rPr lang="hu-HU" sz="2400" dirty="0" err="1"/>
+              <a:t>based</a:t>
+            </a:r>
+            <a:r>
+              <a:rPr lang="hu-HU" sz="2400" dirty="0"/>
+              <a:t> map-</a:t>
+            </a:r>
+            <a:r>
+              <a:rPr lang="hu-HU" sz="2400" dirty="0" err="1"/>
+              <a:t>driven</a:t>
+            </a:r>
+            <a:r>
+              <a:rPr lang="hu-HU" sz="2400" dirty="0"/>
+              <a:t> decision </a:t>
+            </a:r>
+            <a:r>
+              <a:rPr lang="hu-HU" sz="2400" dirty="0" err="1"/>
+              <a:t>support</a:t>
+            </a:r>
+            <a:r>
+              <a:rPr lang="hu-HU" sz="2400" dirty="0"/>
+              <a:t> </a:t>
+            </a:r>
+            <a:r>
+              <a:rPr lang="hu-HU" sz="2400" dirty="0" err="1"/>
+              <a:t>system</a:t>
+            </a:r>
+            <a:r>
+              <a:rPr lang="hu-HU" sz="2400" dirty="0"/>
+              <a:t> (</a:t>
+            </a:r>
+            <a:r>
+              <a:rPr lang="hu-HU" sz="2400" dirty="0" err="1"/>
+              <a:t>dashboard</a:t>
+            </a:r>
+            <a:r>
+              <a:rPr lang="hu-HU" sz="2400" dirty="0"/>
+              <a:t>) </a:t>
+            </a:r>
+            <a:r>
+              <a:rPr lang="hu-HU" sz="2400" dirty="0" err="1"/>
+              <a:t>that</a:t>
+            </a:r>
+            <a:r>
+              <a:rPr lang="hu-HU" sz="2400" dirty="0"/>
+              <a:t> </a:t>
+            </a:r>
+            <a:r>
+              <a:rPr lang="hu-HU" sz="2400" dirty="0" err="1"/>
+              <a:t>recalculates</a:t>
+            </a:r>
+            <a:r>
+              <a:rPr lang="hu-HU" sz="2400" dirty="0"/>
+              <a:t> </a:t>
+            </a:r>
+            <a:r>
+              <a:rPr lang="hu-HU" sz="2400" dirty="0" err="1"/>
+              <a:t>network</a:t>
+            </a:r>
+            <a:r>
+              <a:rPr lang="hu-HU" sz="2400" dirty="0"/>
+              <a:t> </a:t>
+            </a:r>
+            <a:r>
+              <a:rPr lang="hu-HU" sz="2400" dirty="0" err="1"/>
+              <a:t>coverage</a:t>
+            </a:r>
+            <a:r>
+              <a:rPr lang="hu-HU" sz="2400" dirty="0"/>
+              <a:t> in </a:t>
+            </a:r>
+            <a:r>
+              <a:rPr lang="hu-HU" sz="2400" dirty="0" err="1"/>
+              <a:t>real-time</a:t>
+            </a:r>
+            <a:r>
+              <a:rPr lang="hu-HU" sz="2400" dirty="0"/>
+              <a:t> </a:t>
+            </a:r>
+            <a:r>
+              <a:rPr lang="hu-HU" sz="2400" dirty="0" err="1"/>
+              <a:t>based</a:t>
+            </a:r>
+            <a:r>
+              <a:rPr lang="hu-HU" sz="2400" dirty="0"/>
+              <a:t> </a:t>
+            </a:r>
+            <a:r>
+              <a:rPr lang="hu-HU" sz="2400" dirty="0" err="1"/>
+              <a:t>on</a:t>
+            </a:r>
+            <a:r>
+              <a:rPr lang="hu-HU" sz="2400" dirty="0"/>
+              <a:t> input </a:t>
+            </a:r>
+            <a:r>
+              <a:rPr lang="hu-HU" sz="2400" dirty="0" err="1"/>
+              <a:t>parameters</a:t>
+            </a:r>
+            <a:r>
+              <a:rPr lang="hu-HU" sz="2400" dirty="0"/>
+              <a:t> (</a:t>
+            </a:r>
+            <a:r>
+              <a:rPr lang="hu-HU" sz="2400" dirty="0" err="1"/>
+              <a:t>operational</a:t>
+            </a:r>
+            <a:r>
+              <a:rPr lang="hu-HU" sz="2400" dirty="0"/>
+              <a:t> </a:t>
+            </a:r>
+            <a:r>
+              <a:rPr lang="hu-HU" sz="2400" dirty="0" err="1"/>
+              <a:t>range</a:t>
+            </a:r>
+            <a:r>
+              <a:rPr lang="hu-HU" sz="2400" dirty="0"/>
+              <a:t>, </a:t>
+            </a:r>
+            <a:r>
+              <a:rPr lang="hu-HU" sz="2400" dirty="0" err="1"/>
+              <a:t>drone</a:t>
+            </a:r>
+            <a:r>
+              <a:rPr lang="hu-HU" sz="2400" dirty="0"/>
+              <a:t> and </a:t>
+            </a:r>
+            <a:r>
+              <a:rPr lang="hu-HU" sz="2400" dirty="0" err="1"/>
+              <a:t>base</a:t>
+            </a:r>
+            <a:r>
+              <a:rPr lang="hu-HU" sz="2400" dirty="0"/>
+              <a:t> </a:t>
+            </a:r>
+            <a:r>
+              <a:rPr lang="hu-HU" sz="2400" dirty="0" err="1"/>
+              <a:t>capacity</a:t>
+            </a:r>
+            <a:r>
+              <a:rPr lang="hu-HU" sz="2400" dirty="0"/>
+              <a:t>).</a:t>
+            </a:r>
+          </a:p>
+        </p:txBody>
+      </p:sp>
+      <p:pic>
+        <p:nvPicPr>
+          <p:cNvPr id="59" name="Picture 58">
+            <a:extLst>
+              <a:ext uri="{FF2B5EF4-FFF2-40B4-BE49-F238E27FC236}">
+                <a16:creationId xmlns:a16="http://schemas.microsoft.com/office/drawing/2014/main" id="{685CA0E4-0B1D-5525-C3E4-59E9DDB5D557}"/>
+              </a:ext>
+            </a:extLst>
+          </p:cNvPr>
+          <p:cNvPicPr>
+            <a:picLocks noChangeAspect="1"/>
+          </p:cNvPicPr>
+          <p:nvPr/>
+        </p:nvPicPr>
+        <p:blipFill>
+          <a:blip r:embed="rId4">
+            <a:extLst>
+              <a:ext uri="{28A0092B-C50C-407E-A947-70E740481C1C}">
+                <a14:useLocalDpi xmlns:a14="http://schemas.microsoft.com/office/drawing/2010/main" val="0"/>
+              </a:ext>
+            </a:extLst>
+          </a:blip>
+          <a:srcRect/>
+          <a:stretch/>
+        </p:blipFill>
+        <p:spPr>
+          <a:xfrm>
+            <a:off x="8692650" y="21873794"/>
+            <a:ext cx="7712241" cy="4507081"/>
+          </a:xfrm>
+          <a:prstGeom prst="rect">
+            <a:avLst/>
+          </a:prstGeom>
+        </p:spPr>
+      </p:pic>
+      <p:pic>
+        <p:nvPicPr>
+          <p:cNvPr id="61" name="Picture 60">
+            <a:extLst>
+              <a:ext uri="{FF2B5EF4-FFF2-40B4-BE49-F238E27FC236}">
+                <a16:creationId xmlns:a16="http://schemas.microsoft.com/office/drawing/2014/main" id="{1C715554-7C6E-060D-387E-3E3DE01BDA3B}"/>
+              </a:ext>
+            </a:extLst>
+          </p:cNvPr>
+          <p:cNvPicPr>
+            <a:picLocks noChangeAspect="1"/>
+          </p:cNvPicPr>
+          <p:nvPr/>
+        </p:nvPicPr>
+        <p:blipFill>
+          <a:blip r:embed="rId5">
+            <a:extLst>
+              <a:ext uri="{28A0092B-C50C-407E-A947-70E740481C1C}">
+                <a14:useLocalDpi xmlns:a14="http://schemas.microsoft.com/office/drawing/2010/main" val="0"/>
+              </a:ext>
+            </a:extLst>
+          </a:blip>
+          <a:stretch>
+            <a:fillRect/>
+          </a:stretch>
+        </p:blipFill>
+        <p:spPr>
+          <a:xfrm>
+            <a:off x="16404891" y="21857380"/>
+            <a:ext cx="7712242" cy="4539910"/>
+          </a:xfrm>
+          <a:prstGeom prst="rect">
+            <a:avLst/>
+          </a:prstGeom>
+        </p:spPr>
+      </p:pic>
+      <p:pic>
+        <p:nvPicPr>
+          <p:cNvPr id="63" name="Picture 62">
+            <a:extLst>
+              <a:ext uri="{FF2B5EF4-FFF2-40B4-BE49-F238E27FC236}">
+                <a16:creationId xmlns:a16="http://schemas.microsoft.com/office/drawing/2014/main" id="{9C25920A-08C2-3CF0-1267-159EE0F5BBE1}"/>
+              </a:ext>
+            </a:extLst>
+          </p:cNvPr>
+          <p:cNvPicPr>
+            <a:picLocks noChangeAspect="1"/>
+          </p:cNvPicPr>
+          <p:nvPr/>
+        </p:nvPicPr>
+        <p:blipFill>
+          <a:blip r:embed="rId6">
+            <a:extLst>
+              <a:ext uri="{28A0092B-C50C-407E-A947-70E740481C1C}">
+                <a14:useLocalDpi xmlns:a14="http://schemas.microsoft.com/office/drawing/2010/main" val="0"/>
+              </a:ext>
+            </a:extLst>
+          </a:blip>
+          <a:stretch>
+            <a:fillRect/>
+          </a:stretch>
+        </p:blipFill>
+        <p:spPr>
+          <a:xfrm>
+            <a:off x="1082843" y="21848883"/>
+            <a:ext cx="7609807" cy="4519021"/>
+          </a:xfrm>
+          <a:prstGeom prst="rect">
+            <a:avLst/>
+          </a:prstGeom>
+        </p:spPr>
+      </p:pic>
+      <p:sp>
+        <p:nvSpPr>
+          <p:cNvPr id="66" name="TextBox 65">
+            <a:extLst>
+              <a:ext uri="{FF2B5EF4-FFF2-40B4-BE49-F238E27FC236}">
+                <a16:creationId xmlns:a16="http://schemas.microsoft.com/office/drawing/2014/main" id="{E5E3263B-18CA-0533-A9D0-D4CCDBC430E9}"/>
+              </a:ext>
+            </a:extLst>
+          </p:cNvPr>
+          <p:cNvSpPr txBox="1"/>
+          <p:nvPr/>
+        </p:nvSpPr>
+        <p:spPr>
+          <a:xfrm>
+            <a:off x="1092328" y="20914973"/>
+            <a:ext cx="11359640" cy="1015663"/>
+          </a:xfrm>
+          <a:prstGeom prst="rect">
+            <a:avLst/>
+          </a:prstGeom>
+          <a:noFill/>
+        </p:spPr>
+        <p:txBody>
+          <a:bodyPr wrap="square" rtlCol="0">
+            <a:spAutoFit/>
+          </a:bodyPr>
+          <a:lstStyle/>
+          <a:p>
+            <a:pPr algn="ctr"/>
+            <a:r>
+              <a:rPr lang="hu-HU" sz="6000" b="1" dirty="0" err="1"/>
+              <a:t>Results</a:t>
+            </a:r>
+            <a:endParaRPr lang="hu-HU" sz="6000" b="1" dirty="0"/>
+          </a:p>
+        </p:txBody>
+      </p:sp>
+      <p:pic>
+        <p:nvPicPr>
+          <p:cNvPr id="78" name="Picture 77">
+            <a:extLst>
+              <a:ext uri="{FF2B5EF4-FFF2-40B4-BE49-F238E27FC236}">
+                <a16:creationId xmlns:a16="http://schemas.microsoft.com/office/drawing/2014/main" id="{0CCC361D-ABDE-30D9-B5DD-499BB4EAE67A}"/>
+              </a:ext>
+            </a:extLst>
+          </p:cNvPr>
+          <p:cNvPicPr>
+            <a:picLocks noChangeAspect="1"/>
+          </p:cNvPicPr>
+          <p:nvPr/>
+        </p:nvPicPr>
+        <p:blipFill>
+          <a:blip r:embed="rId7">
+            <a:extLst>
+              <a:ext uri="{28A0092B-C50C-407E-A947-70E740481C1C}">
+                <a14:useLocalDpi xmlns:a14="http://schemas.microsoft.com/office/drawing/2010/main" val="0"/>
+              </a:ext>
+            </a:extLst>
+          </a:blip>
+          <a:srcRect/>
+          <a:stretch/>
+        </p:blipFill>
+        <p:spPr>
+          <a:xfrm>
+            <a:off x="13574159" y="27392911"/>
+            <a:ext cx="10627049" cy="6376230"/>
+          </a:xfrm>
+          <a:prstGeom prst="rect">
+            <a:avLst/>
+          </a:prstGeom>
+        </p:spPr>
+      </p:pic>
+      <p:sp>
+        <p:nvSpPr>
+          <p:cNvPr id="80" name="TextBox 79">
+            <a:extLst>
+              <a:ext uri="{FF2B5EF4-FFF2-40B4-BE49-F238E27FC236}">
+                <a16:creationId xmlns:a16="http://schemas.microsoft.com/office/drawing/2014/main" id="{74558FAD-4521-5940-1AF5-8FA5967ACEB8}"/>
+              </a:ext>
+            </a:extLst>
+          </p:cNvPr>
+          <p:cNvSpPr txBox="1"/>
+          <p:nvPr/>
+        </p:nvSpPr>
+        <p:spPr>
+          <a:xfrm>
+            <a:off x="1070642" y="27381778"/>
+            <a:ext cx="11381326" cy="4708981"/>
+          </a:xfrm>
+          <a:prstGeom prst="rect">
+            <a:avLst/>
+          </a:prstGeom>
+          <a:noFill/>
+        </p:spPr>
+        <p:txBody>
+          <a:bodyPr wrap="square" rtlCol="0">
+            <a:spAutoFit/>
+          </a:bodyPr>
+          <a:lstStyle/>
+          <a:p>
+            <a:pPr algn="ctr"/>
+            <a:r>
+              <a:rPr lang="hu-HU" sz="6000" b="1" dirty="0" err="1"/>
+              <a:t>Conclusion</a:t>
+            </a:r>
+            <a:endParaRPr lang="hu-HU" sz="6000" b="1" dirty="0"/>
+          </a:p>
+          <a:p>
+            <a:pPr algn="just"/>
+            <a:r>
+              <a:rPr lang="en-US" sz="2400" b="1" dirty="0"/>
+              <a:t>Mathematical optimum:</a:t>
+            </a:r>
+            <a:r>
+              <a:rPr lang="en-US" sz="2400" dirty="0"/>
+              <a:t> During network </a:t>
+            </a:r>
+            <a:r>
+              <a:rPr lang="en-US" sz="2400" dirty="0" err="1"/>
+              <a:t>optimisation</a:t>
+            </a:r>
+            <a:r>
+              <a:rPr lang="en-US" sz="2400" dirty="0"/>
+              <a:t>, the principle of diminishing returns is clearly evident between the drones' operational range and the required number of bases. The ideal equilibrium point (sweet spot) is located at the 16 km operational radius.</a:t>
+            </a:r>
+          </a:p>
+          <a:p>
+            <a:pPr algn="just"/>
+            <a:r>
+              <a:rPr lang="en-US" sz="2400" b="1" dirty="0"/>
+              <a:t>Infrastructure requirements:</a:t>
+            </a:r>
+            <a:r>
+              <a:rPr lang="en-US" sz="2400" dirty="0"/>
+              <a:t> At this point, deploying 140 drone bases is enough to achieve 95% coverage of the national AED demand.</a:t>
+            </a:r>
+          </a:p>
+          <a:p>
+            <a:pPr algn="just"/>
+            <a:r>
+              <a:rPr lang="en-US" sz="2400" b="1" dirty="0"/>
+              <a:t>Final verdict:</a:t>
+            </a:r>
+            <a:r>
+              <a:rPr lang="en-US" sz="2400" dirty="0"/>
+              <a:t> A data-driven drone network based on small-scale UAVs with a 16–20 km operational radius (e.g., VTOL technology) offers a logistically and financially feasible, realistic solution to </a:t>
+            </a:r>
+            <a:r>
+              <a:rPr lang="en-US" sz="2400" dirty="0" err="1"/>
+              <a:t>revolutionise</a:t>
+            </a:r>
+            <a:r>
+              <a:rPr lang="en-US" sz="2400" dirty="0"/>
+              <a:t> the national chain of survival for sudden cardiac arrests.</a:t>
+            </a:r>
+            <a:endParaRPr lang="hu-HU" sz="2400" dirty="0"/>
+          </a:p>
+        </p:txBody>
+      </p:sp>
+      <p:sp>
+        <p:nvSpPr>
+          <p:cNvPr id="84" name="TextBox 83">
+            <a:extLst>
+              <a:ext uri="{FF2B5EF4-FFF2-40B4-BE49-F238E27FC236}">
+                <a16:creationId xmlns:a16="http://schemas.microsoft.com/office/drawing/2014/main" id="{75ADEDF1-CF6B-C290-5AC6-523B4B7A2B14}"/>
+              </a:ext>
+            </a:extLst>
+          </p:cNvPr>
+          <p:cNvSpPr txBox="1"/>
+          <p:nvPr/>
+        </p:nvSpPr>
+        <p:spPr>
+          <a:xfrm>
+            <a:off x="1082841" y="32759357"/>
+            <a:ext cx="23031367" cy="2308324"/>
+          </a:xfrm>
+          <a:prstGeom prst="rect">
+            <a:avLst/>
+          </a:prstGeom>
+          <a:noFill/>
+        </p:spPr>
+        <p:txBody>
+          <a:bodyPr wrap="square" rtlCol="0">
+            <a:spAutoFit/>
+          </a:bodyPr>
+          <a:lstStyle/>
+          <a:p>
+            <a:r>
+              <a:rPr lang="hu-HU" sz="2400" b="1" dirty="0" err="1"/>
+              <a:t>Sources</a:t>
+            </a:r>
+            <a:endParaRPr lang="hu-HU" sz="2400" b="1" dirty="0"/>
+          </a:p>
+          <a:p>
+            <a:pPr marL="342900" indent="-342900">
+              <a:buFontTx/>
+              <a:buChar char="-"/>
+            </a:pPr>
+            <a:r>
+              <a:rPr lang="hu-HU" sz="2000" dirty="0"/>
+              <a:t>Projekt </a:t>
+            </a:r>
+            <a:r>
+              <a:rPr lang="hu-HU" sz="2000" dirty="0" err="1"/>
+              <a:t>code</a:t>
+            </a:r>
+            <a:r>
+              <a:rPr lang="hu-HU" sz="2000" dirty="0"/>
+              <a:t> </a:t>
+            </a:r>
+            <a:r>
+              <a:rPr lang="hu-HU" sz="2000" dirty="0" err="1"/>
+              <a:t>repository</a:t>
+            </a:r>
+            <a:r>
+              <a:rPr lang="hu-HU" sz="2000" dirty="0"/>
+              <a:t> - </a:t>
+            </a:r>
+            <a:r>
+              <a:rPr lang="en-US" sz="2000" dirty="0"/>
+              <a:t>GitHub: </a:t>
+            </a:r>
+            <a:r>
+              <a:rPr lang="en-US" sz="2000" dirty="0">
+                <a:hlinkClick r:id="rId8"/>
+              </a:rPr>
+              <a:t>https://github.com/ARTidas/DroneDefibrillator</a:t>
+            </a:r>
+            <a:r>
+              <a:rPr lang="hu-HU" sz="2000" dirty="0"/>
+              <a:t> </a:t>
+            </a:r>
+          </a:p>
+          <a:p>
+            <a:pPr marL="342900" indent="-342900">
+              <a:buFontTx/>
+              <a:buChar char="-"/>
+            </a:pPr>
+            <a:r>
+              <a:rPr lang="hu-HU" sz="2000" dirty="0"/>
+              <a:t>List of </a:t>
+            </a:r>
+            <a:r>
+              <a:rPr lang="hu-HU" sz="2000" dirty="0" err="1"/>
+              <a:t>localities</a:t>
+            </a:r>
+            <a:r>
+              <a:rPr lang="hu-HU" sz="2000" dirty="0"/>
+              <a:t> - KSH:  </a:t>
+            </a:r>
+            <a:r>
+              <a:rPr lang="hu-HU" sz="2000" dirty="0">
+                <a:hlinkClick r:id="rId9"/>
+              </a:rPr>
+              <a:t>https://www.ksh.hu/apps/hntr.egyeb?p_lang=HU&amp;p_sablon=LETOLTES</a:t>
+            </a:r>
+            <a:endParaRPr lang="hu-HU" sz="2000" dirty="0"/>
+          </a:p>
+          <a:p>
+            <a:pPr marL="342900" indent="-342900">
+              <a:buFontTx/>
+              <a:buChar char="-"/>
+            </a:pPr>
+            <a:r>
+              <a:rPr lang="hu-HU" sz="2000" dirty="0" err="1"/>
+              <a:t>Dones</a:t>
+            </a:r>
+            <a:r>
+              <a:rPr lang="nl-NL" sz="2000" dirty="0"/>
+              <a:t> - DataVerse: </a:t>
+            </a:r>
+            <a:r>
+              <a:rPr lang="nl-NL" sz="2000" dirty="0">
+                <a:hlinkClick r:id="rId10"/>
+              </a:rPr>
+              <a:t>https://dataverse.no/dataset.xhtml?persistentId=doi:10.18710/L41IGQ</a:t>
+            </a:r>
+            <a:r>
+              <a:rPr lang="hu-HU" sz="2000" dirty="0"/>
+              <a:t> </a:t>
+            </a:r>
+          </a:p>
+          <a:p>
+            <a:pPr marL="342900" indent="-342900">
+              <a:buFontTx/>
+              <a:buChar char="-"/>
+            </a:pPr>
+            <a:r>
+              <a:rPr lang="hu-HU" sz="2000" dirty="0" err="1"/>
+              <a:t>Population</a:t>
+            </a:r>
+            <a:r>
+              <a:rPr lang="hu-HU" sz="2000" dirty="0"/>
+              <a:t> </a:t>
+            </a:r>
+            <a:r>
+              <a:rPr lang="hu-HU" sz="2000" dirty="0" err="1"/>
+              <a:t>density</a:t>
+            </a:r>
+            <a:r>
+              <a:rPr lang="hu-HU" sz="2000" dirty="0"/>
+              <a:t> </a:t>
+            </a:r>
+            <a:r>
+              <a:rPr lang="hu-HU" sz="2000" dirty="0" err="1"/>
+              <a:t>check</a:t>
+            </a:r>
+            <a:r>
+              <a:rPr lang="hu-HU" sz="2000" dirty="0"/>
+              <a:t>: HDX - </a:t>
+            </a:r>
+            <a:r>
+              <a:rPr lang="hu-HU" sz="2000" dirty="0">
+                <a:hlinkClick r:id="rId11"/>
+              </a:rPr>
+              <a:t>https://data.humdata.org/dataset/worldpop-population-counts-2015-2030-hun</a:t>
+            </a:r>
+            <a:endParaRPr lang="hu-HU" sz="2000" dirty="0"/>
+          </a:p>
+          <a:p>
+            <a:pPr marL="342900" indent="-342900">
+              <a:buFontTx/>
+              <a:buChar char="-"/>
+            </a:pPr>
+            <a:r>
+              <a:rPr lang="hu-HU" sz="2000" dirty="0" err="1"/>
+              <a:t>Geographical</a:t>
+            </a:r>
+            <a:r>
+              <a:rPr lang="hu-HU" sz="2000" dirty="0"/>
+              <a:t> </a:t>
+            </a:r>
+            <a:r>
+              <a:rPr lang="hu-HU" sz="2000" dirty="0" err="1"/>
+              <a:t>coordinates</a:t>
+            </a:r>
+            <a:r>
+              <a:rPr lang="pt-BR" sz="2000" dirty="0"/>
+              <a:t> - Nominatim API: </a:t>
+            </a:r>
+            <a:r>
+              <a:rPr lang="pt-BR" sz="2000" dirty="0">
+                <a:hlinkClick r:id="rId12"/>
+              </a:rPr>
+              <a:t>https://nominatim.org/</a:t>
+            </a:r>
+            <a:r>
+              <a:rPr lang="hu-HU" sz="2000" dirty="0"/>
+              <a:t> </a:t>
+            </a:r>
+          </a:p>
+          <a:p>
+            <a:pPr marL="342900" indent="-342900">
+              <a:buFontTx/>
+              <a:buChar char="-"/>
+            </a:pPr>
+            <a:r>
+              <a:rPr lang="hu-HU" sz="2000" dirty="0" err="1"/>
+              <a:t>Yearly</a:t>
+            </a:r>
+            <a:r>
+              <a:rPr lang="hu-HU" sz="2000" dirty="0"/>
+              <a:t> </a:t>
+            </a:r>
+            <a:r>
+              <a:rPr lang="hu-HU" sz="2000" dirty="0" err="1"/>
+              <a:t>case</a:t>
+            </a:r>
+            <a:r>
+              <a:rPr lang="hu-HU" sz="2000" dirty="0"/>
+              <a:t> </a:t>
+            </a:r>
+            <a:r>
+              <a:rPr lang="hu-HU" sz="2000" dirty="0" err="1"/>
+              <a:t>numbers</a:t>
+            </a:r>
+            <a:r>
+              <a:rPr lang="hu-HU" sz="2000" dirty="0"/>
+              <a:t> – EgészségKalauz.hu : </a:t>
+            </a:r>
+            <a:r>
+              <a:rPr lang="hu-HU" sz="2000" dirty="0">
+                <a:hlinkClick r:id="rId13"/>
+              </a:rPr>
+              <a:t>https://www.egeszsegkalauz.hu/extra-ajanlo/a-magyar-emberek-fele-sziv-es-errendszeri-betegseg-miatt-veszti-eletet-hogyan/cz5jnx4</a:t>
+            </a:r>
+            <a:r>
+              <a:rPr lang="hu-HU" sz="2000" dirty="0"/>
+              <a:t> </a:t>
+            </a:r>
+            <a:endParaRPr lang="nl-NL" sz="2000" dirty="0"/>
+          </a:p>
+        </p:txBody>
+      </p:sp>
+    </p:spTree>
+    <p:extLst>
+      <p:ext uri="{BB962C8B-B14F-4D97-AF65-F5344CB8AC3E}">
+        <p14:creationId xmlns:p14="http://schemas.microsoft.com/office/powerpoint/2010/main" val="2174686722"/>
       </p:ext>
     </p:extLst>
   </p:cSld>

</xml_diff>